<commit_message>
Talk: explain why confidence and agreement, show they work, and how CLIMB handles backwards confidence
Co-Authored-By: Claude Opus 5.5 <noreply@anthropic.com>
Claude-Session: https://claude.ai/code/session_01DzDRVWLEv7aS47cAeY8akt
</commit_message>
<xml_diff>
--- a/slides/CLIMB_talk.pptx
+++ b/slides/CLIMB_talk.pptx
@@ -1923,7 +1923,7 @@
           <a:lstStyle/>
           <a:p>
             <a:r>
-              <a:t>Question one: what tells us a cheap answer is right? The first signal is free: the model's own confidence, its average token probability. Above the dashed line, confident answers are more often right. On three Gemma settings it points the wrong way: the model is confidently wrong. So any rule built on this signal must be checked, not trusted.</a:t>
+              <a:t>Question one: what tells us a cheap answer is good enough? A good signal must tell right answers from wrong ones, and it must cost far less than the team, or there is nothing to save. We use two. The first is confidence: how probable the model finds its own answer. A model that knows the answer tends to put its probability on one answer. An unsure model spreads it over several. It is free: it comes with the answer. The second is agreement: run the direct answer and the single agent independently and see whether they match. There is one right answer but many wrong ones, so two independent tries rarely land on the same wrong answer. It costs one more cheap call, and that call's answer is the one we keep. It needs no log-probabilities.</a:t>
             </a:r>
           </a:p>
         </p:txBody>
@@ -1993,7 +1993,7 @@
           <a:lstStyle/>
           <a:p>
             <a:r>
-              <a:t>The second signal is also nearly free. The direct answer and the single agent answer independently. When they agree, the single agent is much more often right, for example 99 against 77 percent on gpt-oss-20b MATH. CLIMB combines the two into one score: agreeing tasks rank first, then by confidence.</a:t>
+              <a:t>Do they work? Left: for each setting, the direct answer's accuracy on its more confident half of tasks against its less confident half. On most settings the confident half is right much more often. On three Gemma settings it is backwards: the model is confidently wrong. Right: the single agent's accuracy when the two cheap answers agree against when they disagree. Agreement separates on most settings, including the three where confidence fails, for example 90 against 34 percent on Gemma FRAMES. It is weak on gpt-oss-20b BBEH, where both answers are mostly wrong. So the two signals cover each other. What does CLIMB do when confidence is backwards? Three things. First, option B ranks tasks by agreement first, so confidence only breaks ties. On Gemma FRAMES and MuSiQue, CLIMB picks option B in every split. Second, the check catches it: a backwards score puts the losses first, so the test fails early and that threshold is never deployed. Third, in the worst case CLIMB calls the team. On these three Gemma settings it uses 69 to 96 percent of the team's tokens at a 5 point tolerance: it saves less, but the promise still holds.</a:t>
             </a:r>
           </a:p>
         </p:txBody>
@@ -17288,35 +17288,53 @@
                 </a:solidFill>
                 <a:latin typeface="Georgia"/>
               </a:rPr>
-              <a:t>Is the direct answer confident?</a:t>
-            </a:r>
-          </a:p>
-        </p:txBody>
-      </p:sp>
-      <p:pic>
-        <p:nvPicPr>
-          <p:cNvPr id="5" name="Picture 4" descr="c_auroc.png"/>
-          <p:cNvPicPr>
-            <a:picLocks noChangeAspect="1"/>
-          </p:cNvPicPr>
-          <p:nvPr/>
-        </p:nvPicPr>
-        <p:blipFill>
-          <a:blip r:embed="rId3"/>
-          <a:stretch>
-            <a:fillRect/>
-          </a:stretch>
-        </p:blipFill>
-        <p:spPr>
-          <a:xfrm>
-            <a:off x="812800" y="2046894"/>
-            <a:ext cx="7302500" cy="3653211"/>
+              <a:t>Why confidence, and why agreement?</a:t>
+            </a:r>
+          </a:p>
+        </p:txBody>
+      </p:sp>
+      <p:sp>
+        <p:nvSpPr>
+          <p:cNvPr id="5" name="TextBox 4"/>
+          <p:cNvSpPr txBox="1"/>
+          <p:nvPr/>
+        </p:nvSpPr>
+        <p:spPr>
+          <a:xfrm>
+            <a:off x="812800" y="1473200"/>
+            <a:ext cx="10566400" cy="254000"/>
           </a:xfrm>
           <a:prstGeom prst="rect">
             <a:avLst/>
           </a:prstGeom>
-        </p:spPr>
-      </p:pic>
+          <a:noFill/>
+        </p:spPr>
+        <p:txBody>
+          <a:bodyPr wrap="square" lIns="0" rIns="0" tIns="0" bIns="0" anchor="t">
+            <a:spAutoFit/>
+          </a:bodyPr>
+          <a:lstStyle/>
+          <a:p>
+            <a:pPr algn="l">
+              <a:lnSpc>
+                <a:spcPct val="115000"/>
+              </a:lnSpc>
+              <a:spcAft>
+                <a:spcPts val="0"/>
+              </a:spcAft>
+            </a:pPr>
+            <a:r>
+              <a:rPr sz="2000" b="1">
+                <a:solidFill>
+                  <a:srgbClr val="00175A"/>
+                </a:solidFill>
+                <a:latin typeface="Arial"/>
+              </a:rPr>
+              <a:t>A good signal tells right from wrong, and costs far less than the team.</a:t>
+            </a:r>
+          </a:p>
+        </p:txBody>
+      </p:sp>
       <p:sp>
         <p:nvSpPr>
           <p:cNvPr id="6" name="Rounded Rectangle 5"/>
@@ -17325,16 +17343,16 @@
         </p:nvSpPr>
         <p:spPr>
           <a:xfrm>
-            <a:off x="8445500" y="2095500"/>
-            <a:ext cx="2933700" cy="1651000"/>
+            <a:off x="812800" y="1905000"/>
+            <a:ext cx="5080000" cy="4254500"/>
           </a:xfrm>
           <a:prstGeom prst="roundRect">
             <a:avLst>
-              <a:gd name="adj" fmla="val 6923"/>
+              <a:gd name="adj" fmla="val 2686"/>
             </a:avLst>
           </a:prstGeom>
           <a:solidFill>
-            <a:srgbClr val="E6EBF4"/>
+            <a:srgbClr val="FFFFFF"/>
           </a:solidFill>
           <a:ln w="12700">
             <a:solidFill>
@@ -17358,25 +17376,51 @@
           </a:fontRef>
         </p:style>
         <p:txBody>
-          <a:bodyPr rtlCol="0" anchor="ctr" wrap="square" lIns="190500" rIns="190500" tIns="190500" bIns="190500"/>
+          <a:bodyPr rtlCol="0" anchor="ctr"/>
+          <a:lstStyle/>
+          <a:p>
+            <a:pPr algn="ctr"/>
+          </a:p>
+        </p:txBody>
+      </p:sp>
+      <p:sp>
+        <p:nvSpPr>
+          <p:cNvPr id="7" name="TextBox 6"/>
+          <p:cNvSpPr txBox="1"/>
+          <p:nvPr/>
+        </p:nvSpPr>
+        <p:spPr>
+          <a:xfrm>
+            <a:off x="1041400" y="2032000"/>
+            <a:ext cx="4635500" cy="635000"/>
+          </a:xfrm>
+          <a:prstGeom prst="rect">
+            <a:avLst/>
+          </a:prstGeom>
+          <a:noFill/>
+        </p:spPr>
+        <p:txBody>
+          <a:bodyPr wrap="square" lIns="0" rIns="0" tIns="0" bIns="0" anchor="t">
+            <a:spAutoFit/>
+          </a:bodyPr>
           <a:lstStyle/>
           <a:p>
             <a:pPr algn="l">
               <a:lnSpc>
-                <a:spcPct val="100000"/>
-              </a:lnSpc>
-              <a:spcAft>
-                <a:spcPts val="600"/>
-              </a:spcAft>
-            </a:pPr>
-            <a:r>
-              <a:rPr sz="3600" b="1">
+                <a:spcPct val="115000"/>
+              </a:lnSpc>
+              <a:spcAft>
+                <a:spcPts val="200"/>
+              </a:spcAft>
+            </a:pPr>
+            <a:r>
+              <a:rPr sz="2800" b="1">
                 <a:solidFill>
                   <a:srgbClr val="00175A"/>
                 </a:solidFill>
                 <a:latin typeface="Georgia"/>
               </a:rPr>
-              <a:t>usually helps</a:t>
+              <a:t>Confidence</a:t>
             </a:r>
           </a:p>
           <a:p>
@@ -17389,35 +17433,77 @@
               </a:spcAft>
             </a:pPr>
             <a:r>
-              <a:rPr sz="1700" b="0">
-                <a:solidFill>
-                  <a:srgbClr val="333B47"/>
-                </a:solidFill>
-                <a:latin typeface="Arial"/>
-              </a:rPr>
-              <a:t>confident answers tend to be right</a:t>
-            </a:r>
-          </a:p>
-        </p:txBody>
-      </p:sp>
-      <p:sp>
-        <p:nvSpPr>
-          <p:cNvPr id="7" name="Rounded Rectangle 6"/>
+              <a:rPr sz="1800" b="0">
+                <a:solidFill>
+                  <a:srgbClr val="6B7480"/>
+                </a:solidFill>
+                <a:latin typeface="Arial"/>
+              </a:rPr>
+              <a:t>Is the model sure of its answer?</a:t>
+            </a:r>
+          </a:p>
+        </p:txBody>
+      </p:sp>
+      <p:sp>
+        <p:nvSpPr>
+          <p:cNvPr id="8" name="TextBox 7"/>
+          <p:cNvSpPr txBox="1"/>
+          <p:nvPr/>
+        </p:nvSpPr>
+        <p:spPr>
+          <a:xfrm>
+            <a:off x="1041400" y="2844800"/>
+            <a:ext cx="4635500" cy="190500"/>
+          </a:xfrm>
+          <a:prstGeom prst="rect">
+            <a:avLst/>
+          </a:prstGeom>
+          <a:noFill/>
+        </p:spPr>
+        <p:txBody>
+          <a:bodyPr wrap="square" lIns="0" rIns="0" tIns="0" bIns="0" anchor="t">
+            <a:spAutoFit/>
+          </a:bodyPr>
+          <a:lstStyle/>
+          <a:p>
+            <a:pPr algn="l">
+              <a:lnSpc>
+                <a:spcPct val="115000"/>
+              </a:lnSpc>
+              <a:spcAft>
+                <a:spcPts val="0"/>
+              </a:spcAft>
+            </a:pPr>
+            <a:r>
+              <a:rPr sz="1500" b="0">
+                <a:solidFill>
+                  <a:srgbClr val="6B7480"/>
+                </a:solidFill>
+                <a:latin typeface="Arial"/>
+              </a:rPr>
+              <a:t>Example: “When did World War II end?”</a:t>
+            </a:r>
+          </a:p>
+        </p:txBody>
+      </p:sp>
+      <p:sp>
+        <p:nvSpPr>
+          <p:cNvPr id="9" name="Rounded Rectangle 8"/>
           <p:cNvSpPr/>
           <p:nvPr/>
         </p:nvSpPr>
         <p:spPr>
           <a:xfrm>
-            <a:off x="8445500" y="4000500"/>
-            <a:ext cx="2933700" cy="1651000"/>
+            <a:off x="6299200" y="1905000"/>
+            <a:ext cx="5080000" cy="4254500"/>
           </a:xfrm>
           <a:prstGeom prst="roundRect">
             <a:avLst>
-              <a:gd name="adj" fmla="val 6923"/>
+              <a:gd name="adj" fmla="val 2686"/>
             </a:avLst>
           </a:prstGeom>
           <a:solidFill>
-            <a:srgbClr val="F6E3E0"/>
+            <a:srgbClr val="FFFFFF"/>
           </a:solidFill>
           <a:ln w="12700">
             <a:solidFill>
@@ -17441,27 +17527,1259 @@
           </a:fontRef>
         </p:style>
         <p:txBody>
-          <a:bodyPr rtlCol="0" anchor="ctr" wrap="square" lIns="190500" rIns="190500" tIns="190500" bIns="190500"/>
+          <a:bodyPr rtlCol="0" anchor="ctr"/>
+          <a:lstStyle/>
+          <a:p>
+            <a:pPr algn="ctr"/>
+          </a:p>
+        </p:txBody>
+      </p:sp>
+      <p:sp>
+        <p:nvSpPr>
+          <p:cNvPr id="10" name="TextBox 9"/>
+          <p:cNvSpPr txBox="1"/>
+          <p:nvPr/>
+        </p:nvSpPr>
+        <p:spPr>
+          <a:xfrm>
+            <a:off x="6527800" y="2032000"/>
+            <a:ext cx="4635500" cy="635000"/>
+          </a:xfrm>
+          <a:prstGeom prst="rect">
+            <a:avLst/>
+          </a:prstGeom>
+          <a:noFill/>
+        </p:spPr>
+        <p:txBody>
+          <a:bodyPr wrap="square" lIns="0" rIns="0" tIns="0" bIns="0" anchor="t">
+            <a:spAutoFit/>
+          </a:bodyPr>
           <a:lstStyle/>
           <a:p>
             <a:pPr algn="l">
               <a:lnSpc>
-                <a:spcPct val="100000"/>
-              </a:lnSpc>
-              <a:spcAft>
-                <a:spcPts val="600"/>
-              </a:spcAft>
-            </a:pPr>
-            <a:r>
-              <a:rPr sz="3600" b="1">
+                <a:spcPct val="115000"/>
+              </a:lnSpc>
+              <a:spcAft>
+                <a:spcPts val="200"/>
+              </a:spcAft>
+            </a:pPr>
+            <a:r>
+              <a:rPr sz="2800" b="1">
+                <a:solidFill>
+                  <a:srgbClr val="00175A"/>
+                </a:solidFill>
+                <a:latin typeface="Georgia"/>
+              </a:rPr>
+              <a:t>Agreement</a:t>
+            </a:r>
+          </a:p>
+          <a:p>
+            <a:pPr algn="l">
+              <a:lnSpc>
+                <a:spcPct val="115000"/>
+              </a:lnSpc>
+              <a:spcAft>
+                <a:spcPts val="0"/>
+              </a:spcAft>
+            </a:pPr>
+            <a:r>
+              <a:rPr sz="1800" b="0">
+                <a:solidFill>
+                  <a:srgbClr val="6B7480"/>
+                </a:solidFill>
+                <a:latin typeface="Arial"/>
+              </a:rPr>
+              <a:t>Do two cheap answers match?</a:t>
+            </a:r>
+          </a:p>
+        </p:txBody>
+      </p:sp>
+      <p:sp>
+        <p:nvSpPr>
+          <p:cNvPr id="11" name="TextBox 10"/>
+          <p:cNvSpPr txBox="1"/>
+          <p:nvPr/>
+        </p:nvSpPr>
+        <p:spPr>
+          <a:xfrm>
+            <a:off x="6527800" y="2844800"/>
+            <a:ext cx="4635500" cy="190500"/>
+          </a:xfrm>
+          <a:prstGeom prst="rect">
+            <a:avLst/>
+          </a:prstGeom>
+          <a:noFill/>
+        </p:spPr>
+        <p:txBody>
+          <a:bodyPr wrap="square" lIns="0" rIns="0" tIns="0" bIns="0" anchor="t">
+            <a:spAutoFit/>
+          </a:bodyPr>
+          <a:lstStyle/>
+          <a:p>
+            <a:pPr algn="l">
+              <a:lnSpc>
+                <a:spcPct val="115000"/>
+              </a:lnSpc>
+              <a:spcAft>
+                <a:spcPts val="0"/>
+              </a:spcAft>
+            </a:pPr>
+            <a:r>
+              <a:rPr sz="1500" b="0">
+                <a:solidFill>
+                  <a:srgbClr val="6B7480"/>
+                </a:solidFill>
+                <a:latin typeface="Arial"/>
+              </a:rPr>
+              <a:t>Example: “When did World War II end?”</a:t>
+            </a:r>
+          </a:p>
+        </p:txBody>
+      </p:sp>
+      <p:sp>
+        <p:nvSpPr>
+          <p:cNvPr id="12" name="TextBox 11"/>
+          <p:cNvSpPr txBox="1"/>
+          <p:nvPr/>
+        </p:nvSpPr>
+        <p:spPr>
+          <a:xfrm>
+            <a:off x="1041400" y="3206750"/>
+            <a:ext cx="1016000" cy="254000"/>
+          </a:xfrm>
+          <a:prstGeom prst="rect">
+            <a:avLst/>
+          </a:prstGeom>
+          <a:noFill/>
+        </p:spPr>
+        <p:txBody>
+          <a:bodyPr wrap="square" lIns="0" rIns="0" tIns="0" bIns="0" anchor="t">
+            <a:spAutoFit/>
+          </a:bodyPr>
+          <a:lstStyle/>
+          <a:p>
+            <a:pPr algn="l">
+              <a:lnSpc>
+                <a:spcPct val="115000"/>
+              </a:lnSpc>
+              <a:spcAft>
+                <a:spcPts val="0"/>
+              </a:spcAft>
+            </a:pPr>
+            <a:r>
+              <a:rPr sz="1800" b="1">
+                <a:solidFill>
+                  <a:srgbClr val="00175A"/>
+                </a:solidFill>
+                <a:latin typeface="Arial"/>
+              </a:rPr>
+              <a:t>Sure</a:t>
+            </a:r>
+          </a:p>
+        </p:txBody>
+      </p:sp>
+      <p:sp>
+        <p:nvSpPr>
+          <p:cNvPr id="13" name="TextBox 12"/>
+          <p:cNvSpPr txBox="1"/>
+          <p:nvPr/>
+        </p:nvSpPr>
+        <p:spPr>
+          <a:xfrm>
+            <a:off x="2095500" y="3206750"/>
+            <a:ext cx="508000" cy="215900"/>
+          </a:xfrm>
+          <a:prstGeom prst="rect">
+            <a:avLst/>
+          </a:prstGeom>
+          <a:noFill/>
+        </p:spPr>
+        <p:txBody>
+          <a:bodyPr wrap="square" lIns="0" rIns="0" tIns="0" bIns="0" anchor="t">
+            <a:spAutoFit/>
+          </a:bodyPr>
+          <a:lstStyle/>
+          <a:p>
+            <a:pPr algn="l">
+              <a:lnSpc>
+                <a:spcPct val="115000"/>
+              </a:lnSpc>
+              <a:spcAft>
+                <a:spcPts val="0"/>
+              </a:spcAft>
+            </a:pPr>
+            <a:r>
+              <a:rPr sz="1600" b="0">
+                <a:solidFill>
+                  <a:srgbClr val="333B47"/>
+                </a:solidFill>
+                <a:latin typeface="Arial"/>
+              </a:rPr>
+              <a:t>1945</a:t>
+            </a:r>
+          </a:p>
+        </p:txBody>
+      </p:sp>
+      <p:sp>
+        <p:nvSpPr>
+          <p:cNvPr id="14" name="Rectangle 13"/>
+          <p:cNvSpPr/>
+          <p:nvPr/>
+        </p:nvSpPr>
+        <p:spPr>
+          <a:xfrm>
+            <a:off x="2603500" y="3244850"/>
+            <a:ext cx="1828800" cy="152400"/>
+          </a:xfrm>
+          <a:prstGeom prst="rect">
+            <a:avLst/>
+          </a:prstGeom>
+          <a:solidFill>
+            <a:srgbClr val="2F6B34"/>
+          </a:solidFill>
+          <a:ln>
+            <a:noFill/>
+          </a:ln>
+          <a:effectLst/>
+        </p:spPr>
+        <p:style>
+          <a:lnRef idx="1">
+            <a:schemeClr val="accent1"/>
+          </a:lnRef>
+          <a:fillRef idx="3">
+            <a:schemeClr val="accent1"/>
+          </a:fillRef>
+          <a:effectRef idx="2">
+            <a:schemeClr val="accent1"/>
+          </a:effectRef>
+          <a:fontRef idx="minor">
+            <a:schemeClr val="lt1"/>
+          </a:fontRef>
+        </p:style>
+        <p:txBody>
+          <a:bodyPr rtlCol="0" anchor="ctr"/>
+          <a:lstStyle/>
+          <a:p>
+            <a:pPr algn="ctr"/>
+          </a:p>
+        </p:txBody>
+      </p:sp>
+      <p:sp>
+        <p:nvSpPr>
+          <p:cNvPr id="15" name="TextBox 14"/>
+          <p:cNvSpPr txBox="1"/>
+          <p:nvPr/>
+        </p:nvSpPr>
+        <p:spPr>
+          <a:xfrm>
+            <a:off x="4495800" y="3206750"/>
+            <a:ext cx="444500" cy="215900"/>
+          </a:xfrm>
+          <a:prstGeom prst="rect">
+            <a:avLst/>
+          </a:prstGeom>
+          <a:noFill/>
+        </p:spPr>
+        <p:txBody>
+          <a:bodyPr wrap="square" lIns="0" rIns="0" tIns="0" bIns="0" anchor="t">
+            <a:spAutoFit/>
+          </a:bodyPr>
+          <a:lstStyle/>
+          <a:p>
+            <a:pPr algn="l">
+              <a:lnSpc>
+                <a:spcPct val="115000"/>
+              </a:lnSpc>
+              <a:spcAft>
+                <a:spcPts val="0"/>
+              </a:spcAft>
+            </a:pPr>
+            <a:r>
+              <a:rPr sz="1500" b="0">
+                <a:solidFill>
+                  <a:srgbClr val="6B7480"/>
+                </a:solidFill>
+                <a:latin typeface="Arial"/>
+              </a:rPr>
+              <a:t>0.96</a:t>
+            </a:r>
+          </a:p>
+        </p:txBody>
+      </p:sp>
+      <p:sp>
+        <p:nvSpPr>
+          <p:cNvPr id="16" name="TextBox 15"/>
+          <p:cNvSpPr txBox="1"/>
+          <p:nvPr/>
+        </p:nvSpPr>
+        <p:spPr>
+          <a:xfrm>
+            <a:off x="1041400" y="3873500"/>
+            <a:ext cx="1016000" cy="254000"/>
+          </a:xfrm>
+          <a:prstGeom prst="rect">
+            <a:avLst/>
+          </a:prstGeom>
+          <a:noFill/>
+        </p:spPr>
+        <p:txBody>
+          <a:bodyPr wrap="square" lIns="0" rIns="0" tIns="0" bIns="0" anchor="t">
+            <a:spAutoFit/>
+          </a:bodyPr>
+          <a:lstStyle/>
+          <a:p>
+            <a:pPr algn="l">
+              <a:lnSpc>
+                <a:spcPct val="115000"/>
+              </a:lnSpc>
+              <a:spcAft>
+                <a:spcPts val="0"/>
+              </a:spcAft>
+            </a:pPr>
+            <a:r>
+              <a:rPr sz="1800" b="1">
+                <a:solidFill>
+                  <a:srgbClr val="00175A"/>
+                </a:solidFill>
+                <a:latin typeface="Arial"/>
+              </a:rPr>
+              <a:t>Unsure</a:t>
+            </a:r>
+          </a:p>
+        </p:txBody>
+      </p:sp>
+      <p:sp>
+        <p:nvSpPr>
+          <p:cNvPr id="17" name="TextBox 16"/>
+          <p:cNvSpPr txBox="1"/>
+          <p:nvPr/>
+        </p:nvSpPr>
+        <p:spPr>
+          <a:xfrm>
+            <a:off x="2095500" y="3873500"/>
+            <a:ext cx="508000" cy="215900"/>
+          </a:xfrm>
+          <a:prstGeom prst="rect">
+            <a:avLst/>
+          </a:prstGeom>
+          <a:noFill/>
+        </p:spPr>
+        <p:txBody>
+          <a:bodyPr wrap="square" lIns="0" rIns="0" tIns="0" bIns="0" anchor="t">
+            <a:spAutoFit/>
+          </a:bodyPr>
+          <a:lstStyle/>
+          <a:p>
+            <a:pPr algn="l">
+              <a:lnSpc>
+                <a:spcPct val="115000"/>
+              </a:lnSpc>
+              <a:spcAft>
+                <a:spcPts val="0"/>
+              </a:spcAft>
+            </a:pPr>
+            <a:r>
+              <a:rPr sz="1600" b="0">
+                <a:solidFill>
+                  <a:srgbClr val="333B47"/>
+                </a:solidFill>
+                <a:latin typeface="Arial"/>
+              </a:rPr>
+              <a:t>1944</a:t>
+            </a:r>
+          </a:p>
+        </p:txBody>
+      </p:sp>
+      <p:sp>
+        <p:nvSpPr>
+          <p:cNvPr id="18" name="Rectangle 17"/>
+          <p:cNvSpPr/>
+          <p:nvPr/>
+        </p:nvSpPr>
+        <p:spPr>
+          <a:xfrm>
+            <a:off x="2603500" y="3911600"/>
+            <a:ext cx="723900" cy="152400"/>
+          </a:xfrm>
+          <a:prstGeom prst="rect">
+            <a:avLst/>
+          </a:prstGeom>
+          <a:solidFill>
+            <a:srgbClr val="B03A2E"/>
+          </a:solidFill>
+          <a:ln>
+            <a:noFill/>
+          </a:ln>
+          <a:effectLst/>
+        </p:spPr>
+        <p:style>
+          <a:lnRef idx="1">
+            <a:schemeClr val="accent1"/>
+          </a:lnRef>
+          <a:fillRef idx="3">
+            <a:schemeClr val="accent1"/>
+          </a:fillRef>
+          <a:effectRef idx="2">
+            <a:schemeClr val="accent1"/>
+          </a:effectRef>
+          <a:fontRef idx="minor">
+            <a:schemeClr val="lt1"/>
+          </a:fontRef>
+        </p:style>
+        <p:txBody>
+          <a:bodyPr rtlCol="0" anchor="ctr"/>
+          <a:lstStyle/>
+          <a:p>
+            <a:pPr algn="ctr"/>
+          </a:p>
+        </p:txBody>
+      </p:sp>
+      <p:sp>
+        <p:nvSpPr>
+          <p:cNvPr id="19" name="TextBox 18"/>
+          <p:cNvSpPr txBox="1"/>
+          <p:nvPr/>
+        </p:nvSpPr>
+        <p:spPr>
+          <a:xfrm>
+            <a:off x="3390900" y="3873500"/>
+            <a:ext cx="444500" cy="215900"/>
+          </a:xfrm>
+          <a:prstGeom prst="rect">
+            <a:avLst/>
+          </a:prstGeom>
+          <a:noFill/>
+        </p:spPr>
+        <p:txBody>
+          <a:bodyPr wrap="square" lIns="0" rIns="0" tIns="0" bIns="0" anchor="t">
+            <a:spAutoFit/>
+          </a:bodyPr>
+          <a:lstStyle/>
+          <a:p>
+            <a:pPr algn="l">
+              <a:lnSpc>
+                <a:spcPct val="115000"/>
+              </a:lnSpc>
+              <a:spcAft>
+                <a:spcPts val="0"/>
+              </a:spcAft>
+            </a:pPr>
+            <a:r>
+              <a:rPr sz="1500" b="0">
+                <a:solidFill>
+                  <a:srgbClr val="6B7480"/>
+                </a:solidFill>
+                <a:latin typeface="Arial"/>
+              </a:rPr>
+              <a:t>0.38</a:t>
+            </a:r>
+          </a:p>
+        </p:txBody>
+      </p:sp>
+      <p:sp>
+        <p:nvSpPr>
+          <p:cNvPr id="20" name="TextBox 19"/>
+          <p:cNvSpPr txBox="1"/>
+          <p:nvPr/>
+        </p:nvSpPr>
+        <p:spPr>
+          <a:xfrm>
+            <a:off x="2095500" y="4114800"/>
+            <a:ext cx="508000" cy="215900"/>
+          </a:xfrm>
+          <a:prstGeom prst="rect">
+            <a:avLst/>
+          </a:prstGeom>
+          <a:noFill/>
+        </p:spPr>
+        <p:txBody>
+          <a:bodyPr wrap="square" lIns="0" rIns="0" tIns="0" bIns="0" anchor="t">
+            <a:spAutoFit/>
+          </a:bodyPr>
+          <a:lstStyle/>
+          <a:p>
+            <a:pPr algn="l">
+              <a:lnSpc>
+                <a:spcPct val="115000"/>
+              </a:lnSpc>
+              <a:spcAft>
+                <a:spcPts val="0"/>
+              </a:spcAft>
+            </a:pPr>
+            <a:r>
+              <a:rPr sz="1600" b="0">
+                <a:solidFill>
+                  <a:srgbClr val="333B47"/>
+                </a:solidFill>
+                <a:latin typeface="Arial"/>
+              </a:rPr>
+              <a:t>1945</a:t>
+            </a:r>
+          </a:p>
+        </p:txBody>
+      </p:sp>
+      <p:sp>
+        <p:nvSpPr>
+          <p:cNvPr id="21" name="Rectangle 20"/>
+          <p:cNvSpPr/>
+          <p:nvPr/>
+        </p:nvSpPr>
+        <p:spPr>
+          <a:xfrm>
+            <a:off x="2603500" y="4152900"/>
+            <a:ext cx="628650" cy="152400"/>
+          </a:xfrm>
+          <a:prstGeom prst="rect">
+            <a:avLst/>
+          </a:prstGeom>
+          <a:solidFill>
+            <a:srgbClr val="B03A2E"/>
+          </a:solidFill>
+          <a:ln>
+            <a:noFill/>
+          </a:ln>
+          <a:effectLst/>
+        </p:spPr>
+        <p:style>
+          <a:lnRef idx="1">
+            <a:schemeClr val="accent1"/>
+          </a:lnRef>
+          <a:fillRef idx="3">
+            <a:schemeClr val="accent1"/>
+          </a:fillRef>
+          <a:effectRef idx="2">
+            <a:schemeClr val="accent1"/>
+          </a:effectRef>
+          <a:fontRef idx="minor">
+            <a:schemeClr val="lt1"/>
+          </a:fontRef>
+        </p:style>
+        <p:txBody>
+          <a:bodyPr rtlCol="0" anchor="ctr"/>
+          <a:lstStyle/>
+          <a:p>
+            <a:pPr algn="ctr"/>
+          </a:p>
+        </p:txBody>
+      </p:sp>
+      <p:sp>
+        <p:nvSpPr>
+          <p:cNvPr id="22" name="TextBox 21"/>
+          <p:cNvSpPr txBox="1"/>
+          <p:nvPr/>
+        </p:nvSpPr>
+        <p:spPr>
+          <a:xfrm>
+            <a:off x="3295650" y="4114800"/>
+            <a:ext cx="444500" cy="215900"/>
+          </a:xfrm>
+          <a:prstGeom prst="rect">
+            <a:avLst/>
+          </a:prstGeom>
+          <a:noFill/>
+        </p:spPr>
+        <p:txBody>
+          <a:bodyPr wrap="square" lIns="0" rIns="0" tIns="0" bIns="0" anchor="t">
+            <a:spAutoFit/>
+          </a:bodyPr>
+          <a:lstStyle/>
+          <a:p>
+            <a:pPr algn="l">
+              <a:lnSpc>
+                <a:spcPct val="115000"/>
+              </a:lnSpc>
+              <a:spcAft>
+                <a:spcPts val="0"/>
+              </a:spcAft>
+            </a:pPr>
+            <a:r>
+              <a:rPr sz="1500" b="0">
+                <a:solidFill>
+                  <a:srgbClr val="6B7480"/>
+                </a:solidFill>
+                <a:latin typeface="Arial"/>
+              </a:rPr>
+              <a:t>0.33</a:t>
+            </a:r>
+          </a:p>
+        </p:txBody>
+      </p:sp>
+      <p:sp>
+        <p:nvSpPr>
+          <p:cNvPr id="23" name="TextBox 22"/>
+          <p:cNvSpPr txBox="1"/>
+          <p:nvPr/>
+        </p:nvSpPr>
+        <p:spPr>
+          <a:xfrm>
+            <a:off x="2095500" y="4356100"/>
+            <a:ext cx="508000" cy="215900"/>
+          </a:xfrm>
+          <a:prstGeom prst="rect">
+            <a:avLst/>
+          </a:prstGeom>
+          <a:noFill/>
+        </p:spPr>
+        <p:txBody>
+          <a:bodyPr wrap="square" lIns="0" rIns="0" tIns="0" bIns="0" anchor="t">
+            <a:spAutoFit/>
+          </a:bodyPr>
+          <a:lstStyle/>
+          <a:p>
+            <a:pPr algn="l">
+              <a:lnSpc>
+                <a:spcPct val="115000"/>
+              </a:lnSpc>
+              <a:spcAft>
+                <a:spcPts val="0"/>
+              </a:spcAft>
+            </a:pPr>
+            <a:r>
+              <a:rPr sz="1600" b="0">
+                <a:solidFill>
+                  <a:srgbClr val="333B47"/>
+                </a:solidFill>
+                <a:latin typeface="Arial"/>
+              </a:rPr>
+              <a:t>1946</a:t>
+            </a:r>
+          </a:p>
+        </p:txBody>
+      </p:sp>
+      <p:sp>
+        <p:nvSpPr>
+          <p:cNvPr id="24" name="Rectangle 23"/>
+          <p:cNvSpPr/>
+          <p:nvPr/>
+        </p:nvSpPr>
+        <p:spPr>
+          <a:xfrm>
+            <a:off x="2603500" y="4394200"/>
+            <a:ext cx="552450" cy="152400"/>
+          </a:xfrm>
+          <a:prstGeom prst="rect">
+            <a:avLst/>
+          </a:prstGeom>
+          <a:solidFill>
+            <a:srgbClr val="B03A2E"/>
+          </a:solidFill>
+          <a:ln>
+            <a:noFill/>
+          </a:ln>
+          <a:effectLst/>
+        </p:spPr>
+        <p:style>
+          <a:lnRef idx="1">
+            <a:schemeClr val="accent1"/>
+          </a:lnRef>
+          <a:fillRef idx="3">
+            <a:schemeClr val="accent1"/>
+          </a:fillRef>
+          <a:effectRef idx="2">
+            <a:schemeClr val="accent1"/>
+          </a:effectRef>
+          <a:fontRef idx="minor">
+            <a:schemeClr val="lt1"/>
+          </a:fontRef>
+        </p:style>
+        <p:txBody>
+          <a:bodyPr rtlCol="0" anchor="ctr"/>
+          <a:lstStyle/>
+          <a:p>
+            <a:pPr algn="ctr"/>
+          </a:p>
+        </p:txBody>
+      </p:sp>
+      <p:sp>
+        <p:nvSpPr>
+          <p:cNvPr id="25" name="TextBox 24"/>
+          <p:cNvSpPr txBox="1"/>
+          <p:nvPr/>
+        </p:nvSpPr>
+        <p:spPr>
+          <a:xfrm>
+            <a:off x="3219450" y="4356100"/>
+            <a:ext cx="444500" cy="215900"/>
+          </a:xfrm>
+          <a:prstGeom prst="rect">
+            <a:avLst/>
+          </a:prstGeom>
+          <a:noFill/>
+        </p:spPr>
+        <p:txBody>
+          <a:bodyPr wrap="square" lIns="0" rIns="0" tIns="0" bIns="0" anchor="t">
+            <a:spAutoFit/>
+          </a:bodyPr>
+          <a:lstStyle/>
+          <a:p>
+            <a:pPr algn="l">
+              <a:lnSpc>
+                <a:spcPct val="115000"/>
+              </a:lnSpc>
+              <a:spcAft>
+                <a:spcPts val="0"/>
+              </a:spcAft>
+            </a:pPr>
+            <a:r>
+              <a:rPr sz="1500" b="0">
+                <a:solidFill>
+                  <a:srgbClr val="6B7480"/>
+                </a:solidFill>
+                <a:latin typeface="Arial"/>
+              </a:rPr>
+              <a:t>0.29</a:t>
+            </a:r>
+          </a:p>
+        </p:txBody>
+      </p:sp>
+      <p:sp>
+        <p:nvSpPr>
+          <p:cNvPr id="26" name="TextBox 25"/>
+          <p:cNvSpPr txBox="1"/>
+          <p:nvPr/>
+        </p:nvSpPr>
+        <p:spPr>
+          <a:xfrm>
+            <a:off x="1041400" y="4889500"/>
+            <a:ext cx="4635500" cy="635000"/>
+          </a:xfrm>
+          <a:prstGeom prst="rect">
+            <a:avLst/>
+          </a:prstGeom>
+          <a:noFill/>
+        </p:spPr>
+        <p:txBody>
+          <a:bodyPr wrap="square" lIns="0" rIns="0" tIns="0" bIns="0" anchor="t">
+            <a:spAutoFit/>
+          </a:bodyPr>
+          <a:lstStyle/>
+          <a:p>
+            <a:pPr algn="l">
+              <a:lnSpc>
+                <a:spcPct val="115000"/>
+              </a:lnSpc>
+              <a:spcAft>
+                <a:spcPts val="0"/>
+              </a:spcAft>
+            </a:pPr>
+            <a:r>
+              <a:rPr sz="1800" b="0">
+                <a:solidFill>
+                  <a:srgbClr val="333B47"/>
+                </a:solidFill>
+                <a:latin typeface="Arial"/>
+              </a:rPr>
+              <a:t>A model that knows tends to put its probability on </a:t>
+            </a:r>
+            <a:r>
+              <a:rPr sz="1800" b="1">
+                <a:solidFill>
+                  <a:srgbClr val="333B47"/>
+                </a:solidFill>
+                <a:latin typeface="Arial"/>
+              </a:rPr>
+              <a:t>one</a:t>
+            </a:r>
+            <a:r>
+              <a:rPr sz="1800" b="0">
+                <a:solidFill>
+                  <a:srgbClr val="333B47"/>
+                </a:solidFill>
+                <a:latin typeface="Arial"/>
+              </a:rPr>
+              <a:t> answer. An unsure one spreads it.</a:t>
+            </a:r>
+          </a:p>
+        </p:txBody>
+      </p:sp>
+      <p:sp>
+        <p:nvSpPr>
+          <p:cNvPr id="27" name="TextBox 26"/>
+          <p:cNvSpPr txBox="1"/>
+          <p:nvPr/>
+        </p:nvSpPr>
+        <p:spPr>
+          <a:xfrm>
+            <a:off x="1041400" y="5715000"/>
+            <a:ext cx="4635500" cy="317500"/>
+          </a:xfrm>
+          <a:prstGeom prst="rect">
+            <a:avLst/>
+          </a:prstGeom>
+          <a:noFill/>
+        </p:spPr>
+        <p:txBody>
+          <a:bodyPr wrap="square" lIns="0" rIns="0" tIns="0" bIns="0" anchor="t">
+            <a:spAutoFit/>
+          </a:bodyPr>
+          <a:lstStyle/>
+          <a:p>
+            <a:pPr algn="l">
+              <a:lnSpc>
+                <a:spcPct val="115000"/>
+              </a:lnSpc>
+              <a:spcAft>
+                <a:spcPts val="0"/>
+              </a:spcAft>
+            </a:pPr>
+            <a:r>
+              <a:rPr sz="1800" b="1">
+                <a:solidFill>
+                  <a:srgbClr val="2F6B34"/>
+                </a:solidFill>
+                <a:latin typeface="Arial"/>
+              </a:rPr>
+              <a:t>Cost: free, it comes with the answer.</a:t>
+            </a:r>
+          </a:p>
+        </p:txBody>
+      </p:sp>
+      <p:sp>
+        <p:nvSpPr>
+          <p:cNvPr id="28" name="TextBox 27"/>
+          <p:cNvSpPr txBox="1"/>
+          <p:nvPr/>
+        </p:nvSpPr>
+        <p:spPr>
+          <a:xfrm>
+            <a:off x="6731000" y="3111500"/>
+            <a:ext cx="1206500" cy="190500"/>
+          </a:xfrm>
+          <a:prstGeom prst="rect">
+            <a:avLst/>
+          </a:prstGeom>
+          <a:noFill/>
+        </p:spPr>
+        <p:txBody>
+          <a:bodyPr wrap="square" lIns="0" rIns="0" tIns="0" bIns="0" anchor="t">
+            <a:spAutoFit/>
+          </a:bodyPr>
+          <a:lstStyle/>
+          <a:p>
+            <a:pPr algn="ctr">
+              <a:lnSpc>
+                <a:spcPct val="115000"/>
+              </a:lnSpc>
+              <a:spcAft>
+                <a:spcPts val="0"/>
+              </a:spcAft>
+            </a:pPr>
+            <a:r>
+              <a:rPr sz="1500" b="0">
+                <a:solidFill>
+                  <a:srgbClr val="6B7480"/>
+                </a:solidFill>
+                <a:latin typeface="Arial"/>
+              </a:rPr>
+              <a:t>direct answer</a:t>
+            </a:r>
+          </a:p>
+        </p:txBody>
+      </p:sp>
+      <p:sp>
+        <p:nvSpPr>
+          <p:cNvPr id="29" name="TextBox 28"/>
+          <p:cNvSpPr txBox="1"/>
+          <p:nvPr/>
+        </p:nvSpPr>
+        <p:spPr>
+          <a:xfrm>
+            <a:off x="8064500" y="3111500"/>
+            <a:ext cx="1206500" cy="190500"/>
+          </a:xfrm>
+          <a:prstGeom prst="rect">
+            <a:avLst/>
+          </a:prstGeom>
+          <a:noFill/>
+        </p:spPr>
+        <p:txBody>
+          <a:bodyPr wrap="square" lIns="0" rIns="0" tIns="0" bIns="0" anchor="t">
+            <a:spAutoFit/>
+          </a:bodyPr>
+          <a:lstStyle/>
+          <a:p>
+            <a:pPr algn="ctr">
+              <a:lnSpc>
+                <a:spcPct val="115000"/>
+              </a:lnSpc>
+              <a:spcAft>
+                <a:spcPts val="0"/>
+              </a:spcAft>
+            </a:pPr>
+            <a:r>
+              <a:rPr sz="1500" b="0">
+                <a:solidFill>
+                  <a:srgbClr val="6B7480"/>
+                </a:solidFill>
+                <a:latin typeface="Arial"/>
+              </a:rPr>
+              <a:t>single agent</a:t>
+            </a:r>
+          </a:p>
+        </p:txBody>
+      </p:sp>
+      <p:sp>
+        <p:nvSpPr>
+          <p:cNvPr id="30" name="Rounded Rectangle 29"/>
+          <p:cNvSpPr/>
+          <p:nvPr/>
+        </p:nvSpPr>
+        <p:spPr>
+          <a:xfrm>
+            <a:off x="6731000" y="3365500"/>
+            <a:ext cx="1206500" cy="539750"/>
+          </a:xfrm>
+          <a:prstGeom prst="roundRect">
+            <a:avLst>
+              <a:gd name="adj" fmla="val 10000"/>
+            </a:avLst>
+          </a:prstGeom>
+          <a:solidFill>
+            <a:srgbClr val="E6EBF4"/>
+          </a:solidFill>
+          <a:ln w="25400">
+            <a:solidFill>
+              <a:srgbClr val="2F6B34"/>
+            </a:solidFill>
+          </a:ln>
+          <a:effectLst/>
+        </p:spPr>
+        <p:style>
+          <a:lnRef idx="1">
+            <a:schemeClr val="accent1"/>
+          </a:lnRef>
+          <a:fillRef idx="3">
+            <a:schemeClr val="accent1"/>
+          </a:fillRef>
+          <a:effectRef idx="2">
+            <a:schemeClr val="accent1"/>
+          </a:effectRef>
+          <a:fontRef idx="minor">
+            <a:schemeClr val="lt1"/>
+          </a:fontRef>
+        </p:style>
+        <p:txBody>
+          <a:bodyPr rtlCol="0" anchor="ctr" wrap="square" lIns="25400" rIns="25400" tIns="25400" bIns="25400"/>
+          <a:lstStyle/>
+          <a:p>
+            <a:pPr algn="ctr">
+              <a:lnSpc>
+                <a:spcPct val="115000"/>
+              </a:lnSpc>
+              <a:spcAft>
+                <a:spcPts val="0"/>
+              </a:spcAft>
+            </a:pPr>
+            <a:r>
+              <a:rPr sz="2200" b="1">
+                <a:solidFill>
+                  <a:srgbClr val="00175A"/>
+                </a:solidFill>
+                <a:latin typeface="Arial"/>
+              </a:rPr>
+              <a:t>1945</a:t>
+            </a:r>
+          </a:p>
+        </p:txBody>
+      </p:sp>
+      <p:sp>
+        <p:nvSpPr>
+          <p:cNvPr id="31" name="Rounded Rectangle 30"/>
+          <p:cNvSpPr/>
+          <p:nvPr/>
+        </p:nvSpPr>
+        <p:spPr>
+          <a:xfrm>
+            <a:off x="8064500" y="3365500"/>
+            <a:ext cx="1206500" cy="539750"/>
+          </a:xfrm>
+          <a:prstGeom prst="roundRect">
+            <a:avLst>
+              <a:gd name="adj" fmla="val 10000"/>
+            </a:avLst>
+          </a:prstGeom>
+          <a:solidFill>
+            <a:srgbClr val="E6EBF4"/>
+          </a:solidFill>
+          <a:ln w="25400">
+            <a:solidFill>
+              <a:srgbClr val="2F6B34"/>
+            </a:solidFill>
+          </a:ln>
+          <a:effectLst/>
+        </p:spPr>
+        <p:style>
+          <a:lnRef idx="1">
+            <a:schemeClr val="accent1"/>
+          </a:lnRef>
+          <a:fillRef idx="3">
+            <a:schemeClr val="accent1"/>
+          </a:fillRef>
+          <a:effectRef idx="2">
+            <a:schemeClr val="accent1"/>
+          </a:effectRef>
+          <a:fontRef idx="minor">
+            <a:schemeClr val="lt1"/>
+          </a:fontRef>
+        </p:style>
+        <p:txBody>
+          <a:bodyPr rtlCol="0" anchor="ctr" wrap="square" lIns="25400" rIns="25400" tIns="25400" bIns="25400"/>
+          <a:lstStyle/>
+          <a:p>
+            <a:pPr algn="ctr">
+              <a:lnSpc>
+                <a:spcPct val="115000"/>
+              </a:lnSpc>
+              <a:spcAft>
+                <a:spcPts val="0"/>
+              </a:spcAft>
+            </a:pPr>
+            <a:r>
+              <a:rPr sz="2200" b="1">
+                <a:solidFill>
+                  <a:srgbClr val="00175A"/>
+                </a:solidFill>
+                <a:latin typeface="Arial"/>
+              </a:rPr>
+              <a:t>1945</a:t>
+            </a:r>
+          </a:p>
+        </p:txBody>
+      </p:sp>
+      <p:sp>
+        <p:nvSpPr>
+          <p:cNvPr id="32" name="TextBox 31"/>
+          <p:cNvSpPr txBox="1"/>
+          <p:nvPr/>
+        </p:nvSpPr>
+        <p:spPr>
+          <a:xfrm>
+            <a:off x="9461500" y="3524250"/>
+            <a:ext cx="1841500" cy="254000"/>
+          </a:xfrm>
+          <a:prstGeom prst="rect">
+            <a:avLst/>
+          </a:prstGeom>
+          <a:noFill/>
+        </p:spPr>
+        <p:txBody>
+          <a:bodyPr wrap="square" lIns="0" rIns="0" tIns="0" bIns="0" anchor="t">
+            <a:spAutoFit/>
+          </a:bodyPr>
+          <a:lstStyle/>
+          <a:p>
+            <a:pPr algn="l">
+              <a:lnSpc>
+                <a:spcPct val="115000"/>
+              </a:lnSpc>
+              <a:spcAft>
+                <a:spcPts val="0"/>
+              </a:spcAft>
+            </a:pPr>
+            <a:r>
+              <a:rPr sz="1600" b="1">
+                <a:solidFill>
+                  <a:srgbClr val="2F6B34"/>
+                </a:solidFill>
+                <a:latin typeface="Arial"/>
+              </a:rPr>
+              <a:t>agree: likely right</a:t>
+            </a:r>
+          </a:p>
+        </p:txBody>
+      </p:sp>
+      <p:sp>
+        <p:nvSpPr>
+          <p:cNvPr id="33" name="Rounded Rectangle 32"/>
+          <p:cNvSpPr/>
+          <p:nvPr/>
+        </p:nvSpPr>
+        <p:spPr>
+          <a:xfrm>
+            <a:off x="6731000" y="4032250"/>
+            <a:ext cx="1206500" cy="539750"/>
+          </a:xfrm>
+          <a:prstGeom prst="roundRect">
+            <a:avLst>
+              <a:gd name="adj" fmla="val 10000"/>
+            </a:avLst>
+          </a:prstGeom>
+          <a:solidFill>
+            <a:srgbClr val="E6EBF4"/>
+          </a:solidFill>
+          <a:ln w="25400">
+            <a:solidFill>
+              <a:srgbClr val="B03A2E"/>
+            </a:solidFill>
+          </a:ln>
+          <a:effectLst/>
+        </p:spPr>
+        <p:style>
+          <a:lnRef idx="1">
+            <a:schemeClr val="accent1"/>
+          </a:lnRef>
+          <a:fillRef idx="3">
+            <a:schemeClr val="accent1"/>
+          </a:fillRef>
+          <a:effectRef idx="2">
+            <a:schemeClr val="accent1"/>
+          </a:effectRef>
+          <a:fontRef idx="minor">
+            <a:schemeClr val="lt1"/>
+          </a:fontRef>
+        </p:style>
+        <p:txBody>
+          <a:bodyPr rtlCol="0" anchor="ctr" wrap="square" lIns="25400" rIns="25400" tIns="25400" bIns="25400"/>
+          <a:lstStyle/>
+          <a:p>
+            <a:pPr algn="ctr">
+              <a:lnSpc>
+                <a:spcPct val="115000"/>
+              </a:lnSpc>
+              <a:spcAft>
+                <a:spcPts val="0"/>
+              </a:spcAft>
+            </a:pPr>
+            <a:r>
+              <a:rPr sz="2200" b="1">
+                <a:solidFill>
+                  <a:srgbClr val="00175A"/>
+                </a:solidFill>
+                <a:latin typeface="Arial"/>
+              </a:rPr>
+              <a:t>1944</a:t>
+            </a:r>
+          </a:p>
+        </p:txBody>
+      </p:sp>
+      <p:sp>
+        <p:nvSpPr>
+          <p:cNvPr id="34" name="Rounded Rectangle 33"/>
+          <p:cNvSpPr/>
+          <p:nvPr/>
+        </p:nvSpPr>
+        <p:spPr>
+          <a:xfrm>
+            <a:off x="8064500" y="4032250"/>
+            <a:ext cx="1206500" cy="539750"/>
+          </a:xfrm>
+          <a:prstGeom prst="roundRect">
+            <a:avLst>
+              <a:gd name="adj" fmla="val 10000"/>
+            </a:avLst>
+          </a:prstGeom>
+          <a:solidFill>
+            <a:srgbClr val="E6EBF4"/>
+          </a:solidFill>
+          <a:ln w="25400">
+            <a:solidFill>
+              <a:srgbClr val="B03A2E"/>
+            </a:solidFill>
+          </a:ln>
+          <a:effectLst/>
+        </p:spPr>
+        <p:style>
+          <a:lnRef idx="1">
+            <a:schemeClr val="accent1"/>
+          </a:lnRef>
+          <a:fillRef idx="3">
+            <a:schemeClr val="accent1"/>
+          </a:fillRef>
+          <a:effectRef idx="2">
+            <a:schemeClr val="accent1"/>
+          </a:effectRef>
+          <a:fontRef idx="minor">
+            <a:schemeClr val="lt1"/>
+          </a:fontRef>
+        </p:style>
+        <p:txBody>
+          <a:bodyPr rtlCol="0" anchor="ctr" wrap="square" lIns="25400" rIns="25400" tIns="25400" bIns="25400"/>
+          <a:lstStyle/>
+          <a:p>
+            <a:pPr algn="ctr">
+              <a:lnSpc>
+                <a:spcPct val="115000"/>
+              </a:lnSpc>
+              <a:spcAft>
+                <a:spcPts val="0"/>
+              </a:spcAft>
+            </a:pPr>
+            <a:r>
+              <a:rPr sz="2200" b="1">
+                <a:solidFill>
+                  <a:srgbClr val="00175A"/>
+                </a:solidFill>
+                <a:latin typeface="Arial"/>
+              </a:rPr>
+              <a:t>1946</a:t>
+            </a:r>
+          </a:p>
+        </p:txBody>
+      </p:sp>
+      <p:sp>
+        <p:nvSpPr>
+          <p:cNvPr id="35" name="TextBox 34"/>
+          <p:cNvSpPr txBox="1"/>
+          <p:nvPr/>
+        </p:nvSpPr>
+        <p:spPr>
+          <a:xfrm>
+            <a:off x="9461500" y="4191000"/>
+            <a:ext cx="1841500" cy="254000"/>
+          </a:xfrm>
+          <a:prstGeom prst="rect">
+            <a:avLst/>
+          </a:prstGeom>
+          <a:noFill/>
+        </p:spPr>
+        <p:txBody>
+          <a:bodyPr wrap="square" lIns="0" rIns="0" tIns="0" bIns="0" anchor="t">
+            <a:spAutoFit/>
+          </a:bodyPr>
+          <a:lstStyle/>
+          <a:p>
+            <a:pPr algn="l">
+              <a:lnSpc>
+                <a:spcPct val="115000"/>
+              </a:lnSpc>
+              <a:spcAft>
+                <a:spcPts val="0"/>
+              </a:spcAft>
+            </a:pPr>
+            <a:r>
+              <a:rPr sz="1600" b="1">
                 <a:solidFill>
                   <a:srgbClr val="B03A2E"/>
                 </a:solidFill>
-                <a:latin typeface="Georgia"/>
-              </a:rPr>
-              <a:t>3 of 12</a:t>
-            </a:r>
-          </a:p>
+                <a:latin typeface="Arial"/>
+              </a:rPr>
+              <a:t>disagree: doubtful</a:t>
+            </a:r>
+          </a:p>
+        </p:txBody>
+      </p:sp>
+      <p:sp>
+        <p:nvSpPr>
+          <p:cNvPr id="36" name="TextBox 35"/>
+          <p:cNvSpPr txBox="1"/>
+          <p:nvPr/>
+        </p:nvSpPr>
+        <p:spPr>
+          <a:xfrm>
+            <a:off x="6527800" y="4889500"/>
+            <a:ext cx="4635500" cy="635000"/>
+          </a:xfrm>
+          <a:prstGeom prst="rect">
+            <a:avLst/>
+          </a:prstGeom>
+          <a:noFill/>
+        </p:spPr>
+        <p:txBody>
+          <a:bodyPr wrap="square" lIns="0" rIns="0" tIns="0" bIns="0" anchor="t">
+            <a:spAutoFit/>
+          </a:bodyPr>
+          <a:lstStyle/>
           <a:p>
             <a:pPr algn="l">
               <a:lnSpc>
@@ -17472,13 +18790,73 @@
               </a:spcAft>
             </a:pPr>
             <a:r>
-              <a:rPr sz="1700" b="0">
+              <a:rPr sz="1800" b="0">
                 <a:solidFill>
                   <a:srgbClr val="333B47"/>
                 </a:solidFill>
                 <a:latin typeface="Arial"/>
               </a:rPr>
-              <a:t>settings where it points the wrong way</a:t>
+              <a:t>One right answer, many wrong ones: two tries </a:t>
+            </a:r>
+            <a:r>
+              <a:rPr sz="1800" b="1">
+                <a:solidFill>
+                  <a:srgbClr val="333B47"/>
+                </a:solidFill>
+                <a:latin typeface="Arial"/>
+              </a:rPr>
+              <a:t>rarely</a:t>
+            </a:r>
+            <a:r>
+              <a:rPr sz="1800" b="0">
+                <a:solidFill>
+                  <a:srgbClr val="333B47"/>
+                </a:solidFill>
+                <a:latin typeface="Arial"/>
+              </a:rPr>
+              <a:t> match on a wrong one.</a:t>
+            </a:r>
+          </a:p>
+        </p:txBody>
+      </p:sp>
+      <p:sp>
+        <p:nvSpPr>
+          <p:cNvPr id="37" name="TextBox 36"/>
+          <p:cNvSpPr txBox="1"/>
+          <p:nvPr/>
+        </p:nvSpPr>
+        <p:spPr>
+          <a:xfrm>
+            <a:off x="6527800" y="5715000"/>
+            <a:ext cx="4635500" cy="317500"/>
+          </a:xfrm>
+          <a:prstGeom prst="rect">
+            <a:avLst/>
+          </a:prstGeom>
+          <a:noFill/>
+        </p:spPr>
+        <p:txBody>
+          <a:bodyPr wrap="square" lIns="0" rIns="0" tIns="0" bIns="0" anchor="t">
+            <a:spAutoFit/>
+          </a:bodyPr>
+          <a:lstStyle/>
+          <a:p>
+            <a:pPr algn="l">
+              <a:lnSpc>
+                <a:spcPct val="115000"/>
+              </a:lnSpc>
+              <a:spcAft>
+                <a:spcPts val="0"/>
+              </a:spcAft>
+            </a:pPr>
+            <a:r>
+              <a:rPr sz="1800" b="1">
+                <a:solidFill>
+                  <a:srgbClr val="2F6B34"/>
+                </a:solidFill>
+                <a:latin typeface="Arial"/>
+              </a:rPr>
+              <a:t>Cost: one more cheap call, no log-probs.</a:t>
             </a:r>
           </a:p>
         </p:txBody>
@@ -17630,14 +19008,56 @@
                 </a:solidFill>
                 <a:latin typeface="Georgia"/>
               </a:rPr>
-              <a:t>Do two cheap answers agree?</a:t>
+              <a:t>Do they work? Mostly, and they cover each other</a:t>
+            </a:r>
+          </a:p>
+        </p:txBody>
+      </p:sp>
+      <p:sp>
+        <p:nvSpPr>
+          <p:cNvPr id="5" name="TextBox 4"/>
+          <p:cNvSpPr txBox="1"/>
+          <p:nvPr/>
+        </p:nvSpPr>
+        <p:spPr>
+          <a:xfrm>
+            <a:off x="812800" y="1555750"/>
+            <a:ext cx="5080000" cy="254000"/>
+          </a:xfrm>
+          <a:prstGeom prst="rect">
+            <a:avLst/>
+          </a:prstGeom>
+          <a:noFill/>
+        </p:spPr>
+        <p:txBody>
+          <a:bodyPr wrap="square" lIns="0" rIns="0" tIns="0" bIns="0" anchor="t">
+            <a:spAutoFit/>
+          </a:bodyPr>
+          <a:lstStyle/>
+          <a:p>
+            <a:pPr algn="l">
+              <a:lnSpc>
+                <a:spcPct val="115000"/>
+              </a:lnSpc>
+              <a:spcAft>
+                <a:spcPts val="0"/>
+              </a:spcAft>
+            </a:pPr>
+            <a:r>
+              <a:rPr sz="2200" b="1">
+                <a:solidFill>
+                  <a:srgbClr val="00175A"/>
+                </a:solidFill>
+                <a:latin typeface="Arial"/>
+              </a:rPr>
+              <a:t>Confidence: direct answer accuracy</a:t>
             </a:r>
           </a:p>
         </p:txBody>
       </p:sp>
       <p:pic>
         <p:nvPicPr>
-          <p:cNvPr id="5" name="Picture 4" descr="c_agree.png"/>
+          <p:cNvPr id="6" name="Picture 5" descr="c_sig_conf.png"/>
           <p:cNvPicPr>
             <a:picLocks noChangeAspect="1"/>
           </p:cNvPicPr>
@@ -17651,8 +19071,8 @@
         </p:blipFill>
         <p:spPr>
           <a:xfrm>
-            <a:off x="812800" y="1922942"/>
-            <a:ext cx="7302500" cy="3901114"/>
+            <a:off x="1650011" y="2019300"/>
+            <a:ext cx="3405577" cy="2349500"/>
           </a:xfrm>
           <a:prstGeom prst="rect">
             <a:avLst/>
@@ -17661,101 +19081,228 @@
       </p:pic>
       <p:sp>
         <p:nvSpPr>
-          <p:cNvPr id="6" name="Rounded Rectangle 5"/>
+          <p:cNvPr id="7" name="TextBox 6"/>
+          <p:cNvSpPr txBox="1"/>
+          <p:nvPr/>
+        </p:nvSpPr>
+        <p:spPr>
+          <a:xfrm>
+            <a:off x="6299200" y="1555750"/>
+            <a:ext cx="5080000" cy="254000"/>
+          </a:xfrm>
+          <a:prstGeom prst="rect">
+            <a:avLst/>
+          </a:prstGeom>
+          <a:noFill/>
+        </p:spPr>
+        <p:txBody>
+          <a:bodyPr wrap="square" lIns="0" rIns="0" tIns="0" bIns="0" anchor="t">
+            <a:spAutoFit/>
+          </a:bodyPr>
+          <a:lstStyle/>
+          <a:p>
+            <a:pPr algn="l">
+              <a:lnSpc>
+                <a:spcPct val="115000"/>
+              </a:lnSpc>
+              <a:spcAft>
+                <a:spcPts val="0"/>
+              </a:spcAft>
+            </a:pPr>
+            <a:r>
+              <a:rPr sz="2200" b="1">
+                <a:solidFill>
+                  <a:srgbClr val="00175A"/>
+                </a:solidFill>
+                <a:latin typeface="Arial"/>
+              </a:rPr>
+              <a:t>Agreement: single agent accuracy</a:t>
+            </a:r>
+          </a:p>
+        </p:txBody>
+      </p:sp>
+      <p:pic>
+        <p:nvPicPr>
+          <p:cNvPr id="8" name="Picture 7" descr="c_sig_agree.png"/>
+          <p:cNvPicPr>
+            <a:picLocks noChangeAspect="1"/>
+          </p:cNvPicPr>
+          <p:nvPr/>
+        </p:nvPicPr>
+        <p:blipFill>
+          <a:blip r:embed="rId4"/>
+          <a:stretch>
+            <a:fillRect/>
+          </a:stretch>
+        </p:blipFill>
+        <p:spPr>
+          <a:xfrm>
+            <a:off x="7136411" y="2019300"/>
+            <a:ext cx="3405577" cy="2349500"/>
+          </a:xfrm>
+          <a:prstGeom prst="rect">
+            <a:avLst/>
+          </a:prstGeom>
+        </p:spPr>
+      </p:pic>
+      <p:sp>
+        <p:nvSpPr>
+          <p:cNvPr id="9" name="TextBox 8"/>
+          <p:cNvSpPr txBox="1"/>
+          <p:nvPr/>
+        </p:nvSpPr>
+        <p:spPr>
+          <a:xfrm>
+            <a:off x="812800" y="4413250"/>
+            <a:ext cx="5080000" cy="254000"/>
+          </a:xfrm>
+          <a:prstGeom prst="rect">
+            <a:avLst/>
+          </a:prstGeom>
+          <a:noFill/>
+        </p:spPr>
+        <p:txBody>
+          <a:bodyPr wrap="square" lIns="0" rIns="0" tIns="0" bIns="0" anchor="t">
+            <a:spAutoFit/>
+          </a:bodyPr>
+          <a:lstStyle/>
+          <a:p>
+            <a:pPr algn="l">
+              <a:lnSpc>
+                <a:spcPct val="115000"/>
+              </a:lnSpc>
+              <a:spcAft>
+                <a:spcPts val="0"/>
+              </a:spcAft>
+            </a:pPr>
+            <a:r>
+              <a:rPr sz="1800" b="0">
+                <a:solidFill>
+                  <a:srgbClr val="333B47"/>
+                </a:solidFill>
+                <a:latin typeface="Arial"/>
+              </a:rPr>
+              <a:t>Mostly helps. </a:t>
+            </a:r>
+            <a:r>
+              <a:rPr sz="1800" b="1">
+                <a:solidFill>
+                  <a:srgbClr val="B03A2E"/>
+                </a:solidFill>
+                <a:latin typeface="Arial"/>
+              </a:rPr>
+              <a:t>Backwards on 3 (Gemma).</a:t>
+            </a:r>
+          </a:p>
+        </p:txBody>
+      </p:sp>
+      <p:sp>
+        <p:nvSpPr>
+          <p:cNvPr id="10" name="TextBox 9"/>
+          <p:cNvSpPr txBox="1"/>
+          <p:nvPr/>
+        </p:nvSpPr>
+        <p:spPr>
+          <a:xfrm>
+            <a:off x="6299200" y="4413250"/>
+            <a:ext cx="5080000" cy="254000"/>
+          </a:xfrm>
+          <a:prstGeom prst="rect">
+            <a:avLst/>
+          </a:prstGeom>
+          <a:noFill/>
+        </p:spPr>
+        <p:txBody>
+          <a:bodyPr wrap="square" lIns="0" rIns="0" tIns="0" bIns="0" anchor="t">
+            <a:spAutoFit/>
+          </a:bodyPr>
+          <a:lstStyle/>
+          <a:p>
+            <a:pPr algn="l">
+              <a:lnSpc>
+                <a:spcPct val="115000"/>
+              </a:lnSpc>
+              <a:spcAft>
+                <a:spcPts val="0"/>
+              </a:spcAft>
+            </a:pPr>
+            <a:r>
+              <a:rPr sz="1800" b="0">
+                <a:solidFill>
+                  <a:srgbClr val="333B47"/>
+                </a:solidFill>
+                <a:latin typeface="Arial"/>
+              </a:rPr>
+              <a:t>Mostly helps, </a:t>
+            </a:r>
+            <a:r>
+              <a:rPr sz="1800" b="1">
+                <a:solidFill>
+                  <a:srgbClr val="2F6B34"/>
+                </a:solidFill>
+                <a:latin typeface="Arial"/>
+              </a:rPr>
+              <a:t>including those 3.</a:t>
+            </a:r>
+          </a:p>
+        </p:txBody>
+      </p:sp>
+      <p:sp>
+        <p:nvSpPr>
+          <p:cNvPr id="11" name="TextBox 10"/>
+          <p:cNvSpPr txBox="1"/>
+          <p:nvPr/>
+        </p:nvSpPr>
+        <p:spPr>
+          <a:xfrm>
+            <a:off x="812800" y="4749800"/>
+            <a:ext cx="10566400" cy="254000"/>
+          </a:xfrm>
+          <a:prstGeom prst="rect">
+            <a:avLst/>
+          </a:prstGeom>
+          <a:noFill/>
+        </p:spPr>
+        <p:txBody>
+          <a:bodyPr wrap="square" lIns="0" rIns="0" tIns="0" bIns="0" anchor="t">
+            <a:spAutoFit/>
+          </a:bodyPr>
+          <a:lstStyle/>
+          <a:p>
+            <a:pPr algn="l">
+              <a:lnSpc>
+                <a:spcPct val="115000"/>
+              </a:lnSpc>
+              <a:spcAft>
+                <a:spcPts val="0"/>
+              </a:spcAft>
+            </a:pPr>
+            <a:r>
+              <a:rPr sz="1900" b="1">
+                <a:solidFill>
+                  <a:srgbClr val="00175A"/>
+                </a:solidFill>
+                <a:latin typeface="Arial"/>
+              </a:rPr>
+              <a:t>When confidence is backwards, CLIMB still holds:</a:t>
+            </a:r>
+          </a:p>
+        </p:txBody>
+      </p:sp>
+      <p:sp>
+        <p:nvSpPr>
+          <p:cNvPr id="12" name="Rounded Rectangle 11"/>
           <p:cNvSpPr/>
           <p:nvPr/>
         </p:nvSpPr>
         <p:spPr>
           <a:xfrm>
-            <a:off x="8445500" y="2095500"/>
-            <a:ext cx="2933700" cy="1651000"/>
+            <a:off x="812800" y="5156200"/>
+            <a:ext cx="3378200" cy="1003300"/>
           </a:xfrm>
           <a:prstGeom prst="roundRect">
             <a:avLst>
-              <a:gd name="adj" fmla="val 6923"/>
-            </a:avLst>
-          </a:prstGeom>
-          <a:solidFill>
-            <a:srgbClr val="E3ECE2"/>
-          </a:solidFill>
-          <a:ln w="12700">
-            <a:solidFill>
-              <a:srgbClr val="D3DCE8"/>
-            </a:solidFill>
-          </a:ln>
-          <a:effectLst/>
-        </p:spPr>
-        <p:style>
-          <a:lnRef idx="1">
-            <a:schemeClr val="accent1"/>
-          </a:lnRef>
-          <a:fillRef idx="3">
-            <a:schemeClr val="accent1"/>
-          </a:fillRef>
-          <a:effectRef idx="2">
-            <a:schemeClr val="accent1"/>
-          </a:effectRef>
-          <a:fontRef idx="minor">
-            <a:schemeClr val="lt1"/>
-          </a:fontRef>
-        </p:style>
-        <p:txBody>
-          <a:bodyPr rtlCol="0" anchor="ctr" wrap="square" lIns="190500" rIns="190500" tIns="190500" bIns="190500"/>
-          <a:lstStyle/>
-          <a:p>
-            <a:pPr algn="l">
-              <a:lnSpc>
-                <a:spcPct val="100000"/>
-              </a:lnSpc>
-              <a:spcAft>
-                <a:spcPts val="600"/>
-              </a:spcAft>
-            </a:pPr>
-            <a:r>
-              <a:rPr sz="3600" b="1">
-                <a:solidFill>
-                  <a:srgbClr val="2F6B34"/>
-                </a:solidFill>
-                <a:latin typeface="Georgia"/>
-              </a:rPr>
-              <a:t>agree</a:t>
-            </a:r>
-          </a:p>
-          <a:p>
-            <a:pPr algn="l">
-              <a:lnSpc>
-                <a:spcPct val="115000"/>
-              </a:lnSpc>
-              <a:spcAft>
-                <a:spcPts val="0"/>
-              </a:spcAft>
-            </a:pPr>
-            <a:r>
-              <a:rPr sz="1700" b="0">
-                <a:solidFill>
-                  <a:srgbClr val="333B47"/>
-                </a:solidFill>
-                <a:latin typeface="Arial"/>
-              </a:rPr>
-              <a:t>→ the single agent is usually right</a:t>
-            </a:r>
-          </a:p>
-        </p:txBody>
-      </p:sp>
-      <p:sp>
-        <p:nvSpPr>
-          <p:cNvPr id="7" name="Rounded Rectangle 6"/>
-          <p:cNvSpPr/>
-          <p:nvPr/>
-        </p:nvSpPr>
-        <p:spPr>
-          <a:xfrm>
-            <a:off x="8445500" y="4000500"/>
-            <a:ext cx="2933700" cy="1651000"/>
-          </a:xfrm>
-          <a:prstGeom prst="roundRect">
-            <a:avLst>
-              <a:gd name="adj" fmla="val 6923"/>
+              <a:gd name="adj" fmla="val 10000"/>
             </a:avLst>
           </a:prstGeom>
           <a:solidFill>
@@ -17781,7 +19328,7 @@
           </a:fontRef>
         </p:style>
         <p:txBody>
-          <a:bodyPr rtlCol="0" anchor="ctr" wrap="square" lIns="190500" rIns="190500" tIns="190500" bIns="190500"/>
+          <a:bodyPr rtlCol="0" anchor="ctr" wrap="square" lIns="114300" rIns="114300" tIns="114300" bIns="114300"/>
           <a:lstStyle/>
           <a:p>
             <a:pPr algn="l">
@@ -17789,17 +19336,17 @@
                 <a:spcPct val="115000"/>
               </a:lnSpc>
               <a:spcAft>
-                <a:spcPts val="800"/>
-              </a:spcAft>
-            </a:pPr>
-            <a:r>
-              <a:rPr sz="2600" b="1">
+                <a:spcPts val="400"/>
+              </a:spcAft>
+            </a:pPr>
+            <a:r>
+              <a:rPr sz="1900" b="1">
                 <a:solidFill>
                   <a:srgbClr val="66B2F0"/>
                 </a:solidFill>
                 <a:latin typeface="Arial"/>
               </a:rPr>
-              <a:t>One score</a:t>
+              <a:t>1  Agreement first</a:t>
             </a:r>
           </a:p>
           <a:p>
@@ -17812,13 +19359,175 @@
               </a:spcAft>
             </a:pPr>
             <a:r>
-              <a:rPr sz="1700" b="0">
+              <a:rPr sz="1500" b="0">
                 <a:solidFill>
                   <a:srgbClr val="F6F8FB"/>
                 </a:solidFill>
                 <a:latin typeface="Arial"/>
               </a:rPr>
-              <a:t>agreeing tasks first, then by confidence</a:t>
+              <a:t>Option B ranks by agreement. Confidence only breaks ties.</a:t>
+            </a:r>
+          </a:p>
+        </p:txBody>
+      </p:sp>
+      <p:sp>
+        <p:nvSpPr>
+          <p:cNvPr id="13" name="Rounded Rectangle 12"/>
+          <p:cNvSpPr/>
+          <p:nvPr/>
+        </p:nvSpPr>
+        <p:spPr>
+          <a:xfrm>
+            <a:off x="4406900" y="5156200"/>
+            <a:ext cx="3378200" cy="1003300"/>
+          </a:xfrm>
+          <a:prstGeom prst="roundRect">
+            <a:avLst>
+              <a:gd name="adj" fmla="val 10000"/>
+            </a:avLst>
+          </a:prstGeom>
+          <a:solidFill>
+            <a:srgbClr val="00175A"/>
+          </a:solidFill>
+          <a:ln>
+            <a:noFill/>
+          </a:ln>
+          <a:effectLst/>
+        </p:spPr>
+        <p:style>
+          <a:lnRef idx="1">
+            <a:schemeClr val="accent1"/>
+          </a:lnRef>
+          <a:fillRef idx="3">
+            <a:schemeClr val="accent1"/>
+          </a:fillRef>
+          <a:effectRef idx="2">
+            <a:schemeClr val="accent1"/>
+          </a:effectRef>
+          <a:fontRef idx="minor">
+            <a:schemeClr val="lt1"/>
+          </a:fontRef>
+        </p:style>
+        <p:txBody>
+          <a:bodyPr rtlCol="0" anchor="ctr" wrap="square" lIns="114300" rIns="114300" tIns="114300" bIns="114300"/>
+          <a:lstStyle/>
+          <a:p>
+            <a:pPr algn="l">
+              <a:lnSpc>
+                <a:spcPct val="115000"/>
+              </a:lnSpc>
+              <a:spcAft>
+                <a:spcPts val="400"/>
+              </a:spcAft>
+            </a:pPr>
+            <a:r>
+              <a:rPr sz="1900" b="1">
+                <a:solidFill>
+                  <a:srgbClr val="66B2F0"/>
+                </a:solidFill>
+                <a:latin typeface="Arial"/>
+              </a:rPr>
+              <a:t>2  The check catches it</a:t>
+            </a:r>
+          </a:p>
+          <a:p>
+            <a:pPr algn="l">
+              <a:lnSpc>
+                <a:spcPct val="115000"/>
+              </a:lnSpc>
+              <a:spcAft>
+                <a:spcPts val="0"/>
+              </a:spcAft>
+            </a:pPr>
+            <a:r>
+              <a:rPr sz="1500" b="0">
+                <a:solidFill>
+                  <a:srgbClr val="F6F8FB"/>
+                </a:solidFill>
+                <a:latin typeface="Arial"/>
+              </a:rPr>
+              <a:t>A backwards score fails the test early. It is not deployed.</a:t>
+            </a:r>
+          </a:p>
+        </p:txBody>
+      </p:sp>
+      <p:sp>
+        <p:nvSpPr>
+          <p:cNvPr id="14" name="Rounded Rectangle 13"/>
+          <p:cNvSpPr/>
+          <p:nvPr/>
+        </p:nvSpPr>
+        <p:spPr>
+          <a:xfrm>
+            <a:off x="8001000" y="5156200"/>
+            <a:ext cx="3378200" cy="1003300"/>
+          </a:xfrm>
+          <a:prstGeom prst="roundRect">
+            <a:avLst>
+              <a:gd name="adj" fmla="val 10000"/>
+            </a:avLst>
+          </a:prstGeom>
+          <a:solidFill>
+            <a:srgbClr val="00175A"/>
+          </a:solidFill>
+          <a:ln>
+            <a:noFill/>
+          </a:ln>
+          <a:effectLst/>
+        </p:spPr>
+        <p:style>
+          <a:lnRef idx="1">
+            <a:schemeClr val="accent1"/>
+          </a:lnRef>
+          <a:fillRef idx="3">
+            <a:schemeClr val="accent1"/>
+          </a:fillRef>
+          <a:effectRef idx="2">
+            <a:schemeClr val="accent1"/>
+          </a:effectRef>
+          <a:fontRef idx="minor">
+            <a:schemeClr val="lt1"/>
+          </a:fontRef>
+        </p:style>
+        <p:txBody>
+          <a:bodyPr rtlCol="0" anchor="ctr" wrap="square" lIns="114300" rIns="114300" tIns="114300" bIns="114300"/>
+          <a:lstStyle/>
+          <a:p>
+            <a:pPr algn="l">
+              <a:lnSpc>
+                <a:spcPct val="115000"/>
+              </a:lnSpc>
+              <a:spcAft>
+                <a:spcPts val="400"/>
+              </a:spcAft>
+            </a:pPr>
+            <a:r>
+              <a:rPr sz="1900" b="1">
+                <a:solidFill>
+                  <a:srgbClr val="66B2F0"/>
+                </a:solidFill>
+                <a:latin typeface="Arial"/>
+              </a:rPr>
+              <a:t>3  Worst case: the team</a:t>
+            </a:r>
+          </a:p>
+          <a:p>
+            <a:pPr algn="l">
+              <a:lnSpc>
+                <a:spcPct val="115000"/>
+              </a:lnSpc>
+              <a:spcAft>
+                <a:spcPts val="0"/>
+              </a:spcAft>
+            </a:pPr>
+            <a:r>
+              <a:rPr sz="1500" b="0">
+                <a:solidFill>
+                  <a:srgbClr val="F6F8FB"/>
+                </a:solidFill>
+                <a:latin typeface="Arial"/>
+              </a:rPr>
+              <a:t>Less saving, no lost accuracy. Gemma: 69–96% of tokens.</a:t>
             </a:r>
           </a:p>
         </p:txBody>

</xml_diff>

<commit_message>
Talk: explain why a threshold is the best rule
New slide on threshold optimality (knapsack argument, gain by confidence on
the 9 settings where confidence ranks right), before the threshold is set.

Co-Authored-By: Claude Opus 5.5 <noreply@anthropic.com>
Claude-Session: https://claude.ai/code/session_01DzDRVWLEv7aS47cAeY8akt
</commit_message>
<xml_diff>
--- a/slides/CLIMB_talk.pptx
+++ b/slides/CLIMB_talk.pptx
@@ -12,6 +12,7 @@
     <p:sldId id="261" r:id="rId13"/>
     <p:sldId id="263" r:id="rId15"/>
     <p:sldId id="264" r:id="rId16"/>
+    <p:sldId id="286" r:id="rId38"/>
     <p:sldId id="283" r:id="rId35"/>
     <p:sldId id="266" r:id="rId18"/>
     <p:sldId id="284" r:id="rId36"/>
@@ -2142,6 +2143,76 @@
           <a:p>
             <a:r>
               <a:t>Here is exactly what CLIMB does for one threshold. Take the calibration tasks in random order and start with one dollar. For each task, the threshold either stops early and keeps the cheap answer, or escalates and uses the team's answer. The loss is the team's correctness minus ours: plus one if we lost a right answer, minus one if we saved one, zero otherwise. An escalated task always has loss zero. The bet size is set from the earlier tasks only, never from the current one, and is capped so one loss at most halves the money. Multiply the money by one plus bet size times tolerance minus loss. In the example, with bet size 0.5 and a 5 point tolerance, task 3 loses a right answer and the money halves, task 4 saves one and it grows by half. If the money ever reaches 20 dollars, the threshold is certified and we move to the next, looser one. If it never does, we stop: no looser threshold is deployed. We run this for options A and B, each at 5 percent.</a:t>
+            </a:r>
+          </a:p>
+        </p:txBody>
+      </p:sp>
+      <p:sp>
+        <p:nvSpPr>
+          <p:cNvPr id="4" name="Slide Number Placeholder 3"/>
+          <p:cNvSpPr>
+            <a:spLocks noGrp="1"/>
+          </p:cNvSpPr>
+          <p:nvPr>
+            <p:ph type="sldNum" idx="5" sz="quarter"/>
+          </p:nvPr>
+        </p:nvSpPr>
+        <p:spPr/>
+      </p:sp>
+    </p:spTree>
+  </p:cSld>
+  <p:clrMapOvr>
+    <a:masterClrMapping/>
+  </p:clrMapOvr>
+</p:notes>
+</file>
+
+<file path=ppt/notesSlides/notesSlide31.xml><?xml version="1.0" encoding="utf-8"?>
+<p:notes xmlns:a="http://schemas.openxmlformats.org/drawingml/2006/main" xmlns:p="http://schemas.openxmlformats.org/presentationml/2006/main" xmlns:r="http://schemas.openxmlformats.org/officeDocument/2006/relationships">
+  <p:cSld>
+    <p:spTree>
+      <p:nvGrpSpPr>
+        <p:cNvPr id="1" name=""/>
+        <p:cNvGrpSpPr/>
+        <p:nvPr/>
+      </p:nvGrpSpPr>
+      <p:grpSpPr>
+        <a:xfrm>
+          <a:off x="0" y="0"/>
+          <a:ext cx="0" cy="0"/>
+          <a:chOff x="0" y="0"/>
+          <a:chExt cx="0" cy="0"/>
+        </a:xfrm>
+      </p:grpSpPr>
+      <p:sp>
+        <p:nvSpPr>
+          <p:cNvPr id="2" name="Slide Image Placeholder 1"/>
+          <p:cNvSpPr>
+            <a:spLocks noGrp="1"/>
+          </p:cNvSpPr>
+          <p:nvPr>
+            <p:ph type="sldImg" idx="2"/>
+          </p:nvPr>
+        </p:nvSpPr>
+        <p:spPr/>
+      </p:sp>
+      <p:sp>
+        <p:nvSpPr>
+          <p:cNvPr id="3" name="Notes Placeholder 2"/>
+          <p:cNvSpPr>
+            <a:spLocks noGrp="1"/>
+          </p:cNvSpPr>
+          <p:nvPr>
+            <p:ph type="body" idx="3" sz="quarter"/>
+          </p:nvPr>
+        </p:nvSpPr>
+        <p:spPr/>
+        <p:txBody>
+          <a:bodyPr/>
+          <a:lstStyle/>
+          <a:p>
+            <a:r>
+              <a:t>Why is the rule a threshold, and not something more complex? Think of it as packing a bag. Stopping a task early saves the team's tokens on it, but risks the accuracy the team would have added, its gain. You can afford a total risk of epsilon. To save the most tokens, you stop first the tasks with the least gain per token saved, exactly like a knapsack. Now, if the gain falls as confidence rises, those are the most confident tasks. So the best rule stops every task above some confidence, and escalates the rest: a threshold. The paper proves this as a proposition. Does the gain fall with confidence? On the right, the gain from calling the team in each fifth of tasks, on the nine settings where confidence ranks answers the right way. It falls from 17 points on the least confident fifth to 4 to 6 on the confident ones, and it falls on eight of the nine. On Gemma's three backwards settings it does not, and there the guarantee still holds, the savings come from agreement. So theory gives the form of the rule. What it cannot give is where the line goes: that depends on the unknown gain, and the data has to decide.</a:t>
             </a:r>
           </a:p>
         </p:txBody>
@@ -6083,7 +6154,7 @@
                 </a:solidFill>
                 <a:latin typeface="Arial"/>
               </a:rPr>
-              <a:t>23</a:t>
+              <a:t>24</a:t>
             </a:r>
           </a:p>
         </p:txBody>
@@ -7492,7 +7563,7 @@
                 </a:solidFill>
                 <a:latin typeface="Arial"/>
               </a:rPr>
-              <a:t>9</a:t>
+              <a:t>10</a:t>
             </a:r>
           </a:p>
         </p:txBody>
@@ -8096,7 +8167,7 @@
                 </a:solidFill>
                 <a:latin typeface="Arial"/>
               </a:rPr>
-              <a:t>11</a:t>
+              <a:t>12</a:t>
             </a:r>
           </a:p>
         </p:txBody>
@@ -8580,7 +8651,7 @@
                 </a:solidFill>
                 <a:latin typeface="Arial"/>
               </a:rPr>
-              <a:t>12</a:t>
+              <a:t>13</a:t>
             </a:r>
           </a:p>
         </p:txBody>
@@ -9325,7 +9396,7 @@
                 </a:solidFill>
                 <a:latin typeface="Arial"/>
               </a:rPr>
-              <a:t>13</a:t>
+              <a:t>14</a:t>
             </a:r>
           </a:p>
         </p:txBody>
@@ -9899,7 +9970,7 @@
                 </a:solidFill>
                 <a:latin typeface="Arial"/>
               </a:rPr>
-              <a:t>25</a:t>
+              <a:t>26</a:t>
             </a:r>
           </a:p>
         </p:txBody>
@@ -10117,7 +10188,7 @@
                 </a:solidFill>
                 <a:latin typeface="Arial"/>
               </a:rPr>
-              <a:t>15</a:t>
+              <a:t>16</a:t>
             </a:r>
           </a:p>
         </p:txBody>
@@ -10460,7 +10531,7 @@
                 </a:solidFill>
                 <a:latin typeface="Arial"/>
               </a:rPr>
-              <a:t>26</a:t>
+              <a:t>27</a:t>
             </a:r>
           </a:p>
         </p:txBody>
@@ -11224,7 +11295,7 @@
                 </a:solidFill>
                 <a:latin typeface="Arial"/>
               </a:rPr>
-              <a:t>27</a:t>
+              <a:t>28</a:t>
             </a:r>
           </a:p>
         </p:txBody>
@@ -12822,7 +12893,7 @@
                 </a:solidFill>
                 <a:latin typeface="Arial"/>
               </a:rPr>
-              <a:t>28</a:t>
+              <a:t>29</a:t>
             </a:r>
           </a:p>
         </p:txBody>
@@ -14338,7 +14409,7 @@
                 </a:solidFill>
                 <a:latin typeface="Arial"/>
               </a:rPr>
-              <a:t>29</a:t>
+              <a:t>30</a:t>
             </a:r>
           </a:p>
         </p:txBody>
@@ -14680,7 +14751,7 @@
                 </a:solidFill>
                 <a:latin typeface="Arial"/>
               </a:rPr>
-              <a:t>30</a:t>
+              <a:t>31</a:t>
             </a:r>
           </a:p>
         </p:txBody>
@@ -15130,7 +15201,7 @@
                 </a:solidFill>
                 <a:latin typeface="Arial"/>
               </a:rPr>
-              <a:t>16</a:t>
+              <a:t>17</a:t>
             </a:r>
           </a:p>
         </p:txBody>
@@ -15389,7 +15460,7 @@
                 </a:solidFill>
                 <a:latin typeface="Arial"/>
               </a:rPr>
-              <a:t>24</a:t>
+              <a:t>25</a:t>
             </a:r>
           </a:p>
         </p:txBody>
@@ -15898,7 +15969,7 @@
                 </a:solidFill>
                 <a:latin typeface="Arial"/>
               </a:rPr>
-              <a:t>17</a:t>
+              <a:t>18</a:t>
             </a:r>
           </a:p>
         </p:txBody>
@@ -17170,7 +17241,7 @@
                 </a:solidFill>
                 <a:latin typeface="Arial"/>
               </a:rPr>
-              <a:t>18</a:t>
+              <a:t>19</a:t>
             </a:r>
           </a:p>
         </p:txBody>
@@ -17322,7 +17393,7 @@
                 </a:solidFill>
                 <a:latin typeface="Arial"/>
               </a:rPr>
-              <a:t>19</a:t>
+              <a:t>20</a:t>
             </a:r>
           </a:p>
         </p:txBody>
@@ -18733,7 +18804,7 @@
                 </a:solidFill>
                 <a:latin typeface="Arial"/>
               </a:rPr>
-              <a:t>8</a:t>
+              <a:t>9</a:t>
             </a:r>
           </a:p>
         </p:txBody>
@@ -19408,7 +19479,7 @@
                 </a:solidFill>
                 <a:latin typeface="Arial"/>
               </a:rPr>
-              <a:t>10</a:t>
+              <a:t>11</a:t>
             </a:r>
           </a:p>
         </p:txBody>
@@ -19750,7 +19821,7 @@
                 </a:solidFill>
                 <a:latin typeface="Arial"/>
               </a:rPr>
-              <a:t>20</a:t>
+              <a:t>21</a:t>
             </a:r>
           </a:p>
         </p:txBody>
@@ -23123,7 +23194,1052 @@
                 </a:solidFill>
                 <a:latin typeface="Arial"/>
               </a:rPr>
-              <a:t>14</a:t>
+              <a:t>15</a:t>
+            </a:r>
+          </a:p>
+        </p:txBody>
+      </p:sp>
+    </p:spTree>
+  </p:cSld>
+  <p:clrMapOvr>
+    <a:masterClrMapping/>
+  </p:clrMapOvr>
+</p:sld>
+</file>
+
+<file path=ppt/slides/slide31.xml><?xml version="1.0" encoding="utf-8"?>
+<p:sld xmlns:a="http://schemas.openxmlformats.org/drawingml/2006/main" xmlns:p="http://schemas.openxmlformats.org/presentationml/2006/main" xmlns:r="http://schemas.openxmlformats.org/officeDocument/2006/relationships">
+  <p:cSld>
+    <p:bg>
+      <p:bgPr>
+        <a:solidFill>
+          <a:srgbClr val="F6F8FB"/>
+        </a:solidFill>
+        <a:effectLst/>
+      </p:bgPr>
+    </p:bg>
+    <p:spTree>
+      <p:nvGrpSpPr>
+        <p:cNvPr id="1" name=""/>
+        <p:cNvGrpSpPr/>
+        <p:nvPr/>
+      </p:nvGrpSpPr>
+      <p:grpSpPr/>
+      <p:sp>
+        <p:nvSpPr>
+          <p:cNvPr id="2" name="TextBox 1"/>
+          <p:cNvSpPr txBox="1"/>
+          <p:nvPr/>
+        </p:nvSpPr>
+        <p:spPr>
+          <a:xfrm>
+            <a:off x="812800" y="635000"/>
+            <a:ext cx="10566400" cy="254000"/>
+          </a:xfrm>
+          <a:prstGeom prst="rect">
+            <a:avLst/>
+          </a:prstGeom>
+          <a:noFill/>
+        </p:spPr>
+        <p:txBody>
+          <a:bodyPr wrap="square" lIns="0" rIns="0" tIns="0" bIns="0" anchor="t">
+            <a:spAutoFit/>
+          </a:bodyPr>
+          <a:lstStyle/>
+          <a:p>
+            <a:pPr algn="l">
+              <a:lnSpc>
+                <a:spcPct val="115000"/>
+              </a:lnSpc>
+              <a:spcAft>
+                <a:spcPts val="0"/>
+              </a:spcAft>
+            </a:pPr>
+            <a:r>
+              <a:rPr sz="1300" b="1">
+                <a:solidFill>
+                  <a:srgbClr val="006FCF"/>
+                </a:solidFill>
+                <a:latin typeface="Arial"/>
+              </a:rPr>
+              <a:t>STEP 2 · SETTING THE THRESHOLD</a:t>
+            </a:r>
+          </a:p>
+        </p:txBody>
+      </p:sp>
+      <p:sp>
+        <p:nvSpPr>
+          <p:cNvPr id="3" name="TextBox 2"/>
+          <p:cNvSpPr txBox="1"/>
+          <p:nvPr/>
+        </p:nvSpPr>
+        <p:spPr>
+          <a:xfrm>
+            <a:off x="812800" y="889000"/>
+            <a:ext cx="10566400" cy="571500"/>
+          </a:xfrm>
+          <a:prstGeom prst="rect">
+            <a:avLst/>
+          </a:prstGeom>
+          <a:noFill/>
+        </p:spPr>
+        <p:txBody>
+          <a:bodyPr wrap="square" lIns="0" rIns="0" tIns="0" bIns="0" anchor="t">
+            <a:spAutoFit/>
+          </a:bodyPr>
+          <a:lstStyle/>
+          <a:p>
+            <a:pPr algn="l">
+              <a:lnSpc>
+                <a:spcPct val="105000"/>
+              </a:lnSpc>
+              <a:spcAft>
+                <a:spcPts val="0"/>
+              </a:spcAft>
+            </a:pPr>
+            <a:r>
+              <a:rPr sz="3000" b="1">
+                <a:solidFill>
+                  <a:srgbClr val="00175A"/>
+                </a:solidFill>
+                <a:latin typeface="Georgia"/>
+              </a:rPr>
+              <a:t>Why a threshold? It is the best rule</a:t>
+            </a:r>
+          </a:p>
+        </p:txBody>
+      </p:sp>
+      <p:sp>
+        <p:nvSpPr>
+          <p:cNvPr id="4" name="Oval 3"/>
+          <p:cNvSpPr/>
+          <p:nvPr/>
+        </p:nvSpPr>
+        <p:spPr>
+          <a:xfrm>
+            <a:off x="812800" y="1587500"/>
+            <a:ext cx="355600" cy="355600"/>
+          </a:xfrm>
+          <a:prstGeom prst="ellipse">
+            <a:avLst/>
+          </a:prstGeom>
+          <a:solidFill>
+            <a:srgbClr val="006FCF"/>
+          </a:solidFill>
+          <a:ln>
+            <a:noFill/>
+          </a:ln>
+          <a:effectLst/>
+        </p:spPr>
+        <p:style>
+          <a:lnRef idx="1">
+            <a:schemeClr val="accent1"/>
+          </a:lnRef>
+          <a:fillRef idx="3">
+            <a:schemeClr val="accent1"/>
+          </a:fillRef>
+          <a:effectRef idx="2">
+            <a:schemeClr val="accent1"/>
+          </a:effectRef>
+          <a:fontRef idx="minor">
+            <a:schemeClr val="lt1"/>
+          </a:fontRef>
+        </p:style>
+        <p:txBody>
+          <a:bodyPr rtlCol="0" anchor="ctr" wrap="square" lIns="0" rIns="0" tIns="0" bIns="0"/>
+          <a:lstStyle/>
+          <a:p>
+            <a:pPr algn="ctr">
+              <a:lnSpc>
+                <a:spcPct val="115000"/>
+              </a:lnSpc>
+              <a:spcAft>
+                <a:spcPts val="0"/>
+              </a:spcAft>
+            </a:pPr>
+            <a:r>
+              <a:rPr sz="2400" b="1">
+                <a:solidFill>
+                  <a:srgbClr val="F6F8FB"/>
+                </a:solidFill>
+                <a:latin typeface="Arial"/>
+              </a:rPr>
+              <a:t>1</a:t>
+            </a:r>
+          </a:p>
+        </p:txBody>
+      </p:sp>
+      <p:sp>
+        <p:nvSpPr>
+          <p:cNvPr id="5" name="TextBox 4"/>
+          <p:cNvSpPr txBox="1"/>
+          <p:nvPr/>
+        </p:nvSpPr>
+        <p:spPr>
+          <a:xfrm>
+            <a:off x="1295400" y="1574800"/>
+            <a:ext cx="4826000" cy="698500"/>
+          </a:xfrm>
+          <a:prstGeom prst="rect">
+            <a:avLst/>
+          </a:prstGeom>
+          <a:noFill/>
+        </p:spPr>
+        <p:txBody>
+          <a:bodyPr wrap="square" lIns="0" rIns="0" tIns="0" bIns="0" anchor="t">
+            <a:spAutoFit/>
+          </a:bodyPr>
+          <a:lstStyle/>
+          <a:p>
+            <a:pPr algn="l">
+              <a:lnSpc>
+                <a:spcPct val="115000"/>
+              </a:lnSpc>
+              <a:spcAft>
+                <a:spcPts val="0"/>
+              </a:spcAft>
+            </a:pPr>
+            <a:r>
+              <a:rPr sz="1700" b="0">
+                <a:solidFill>
+                  <a:srgbClr val="333B47"/>
+                </a:solidFill>
+                <a:latin typeface="Arial"/>
+              </a:rPr>
+              <a:t>Stopping a task early saves its team tokens, but risks the accuracy the team would add: its </a:t>
+            </a:r>
+            <a:r>
+              <a:rPr sz="1700" b="1">
+                <a:solidFill>
+                  <a:srgbClr val="333B47"/>
+                </a:solidFill>
+                <a:latin typeface="Arial"/>
+              </a:rPr>
+              <a:t>gain</a:t>
+            </a:r>
+            <a:r>
+              <a:rPr sz="1700" b="0">
+                <a:solidFill>
+                  <a:srgbClr val="333B47"/>
+                </a:solidFill>
+                <a:latin typeface="Arial"/>
+              </a:rPr>
+              <a:t>.</a:t>
+            </a:r>
+          </a:p>
+        </p:txBody>
+      </p:sp>
+      <p:sp>
+        <p:nvSpPr>
+          <p:cNvPr id="6" name="Oval 5"/>
+          <p:cNvSpPr/>
+          <p:nvPr/>
+        </p:nvSpPr>
+        <p:spPr>
+          <a:xfrm>
+            <a:off x="812800" y="2317750"/>
+            <a:ext cx="355600" cy="355600"/>
+          </a:xfrm>
+          <a:prstGeom prst="ellipse">
+            <a:avLst/>
+          </a:prstGeom>
+          <a:solidFill>
+            <a:srgbClr val="006FCF"/>
+          </a:solidFill>
+          <a:ln>
+            <a:noFill/>
+          </a:ln>
+          <a:effectLst/>
+        </p:spPr>
+        <p:style>
+          <a:lnRef idx="1">
+            <a:schemeClr val="accent1"/>
+          </a:lnRef>
+          <a:fillRef idx="3">
+            <a:schemeClr val="accent1"/>
+          </a:fillRef>
+          <a:effectRef idx="2">
+            <a:schemeClr val="accent1"/>
+          </a:effectRef>
+          <a:fontRef idx="minor">
+            <a:schemeClr val="lt1"/>
+          </a:fontRef>
+        </p:style>
+        <p:txBody>
+          <a:bodyPr rtlCol="0" anchor="ctr" wrap="square" lIns="0" rIns="0" tIns="0" bIns="0"/>
+          <a:lstStyle/>
+          <a:p>
+            <a:pPr algn="ctr">
+              <a:lnSpc>
+                <a:spcPct val="115000"/>
+              </a:lnSpc>
+              <a:spcAft>
+                <a:spcPts val="0"/>
+              </a:spcAft>
+            </a:pPr>
+            <a:r>
+              <a:rPr sz="2400" b="1">
+                <a:solidFill>
+                  <a:srgbClr val="F6F8FB"/>
+                </a:solidFill>
+                <a:latin typeface="Arial"/>
+              </a:rPr>
+              <a:t>2</a:t>
+            </a:r>
+          </a:p>
+        </p:txBody>
+      </p:sp>
+      <p:sp>
+        <p:nvSpPr>
+          <p:cNvPr id="7" name="TextBox 6"/>
+          <p:cNvSpPr txBox="1"/>
+          <p:nvPr/>
+        </p:nvSpPr>
+        <p:spPr>
+          <a:xfrm>
+            <a:off x="1295400" y="2305050"/>
+            <a:ext cx="4826000" cy="698500"/>
+          </a:xfrm>
+          <a:prstGeom prst="rect">
+            <a:avLst/>
+          </a:prstGeom>
+          <a:noFill/>
+        </p:spPr>
+        <p:txBody>
+          <a:bodyPr wrap="square" lIns="0" rIns="0" tIns="0" bIns="0" anchor="t">
+            <a:spAutoFit/>
+          </a:bodyPr>
+          <a:lstStyle/>
+          <a:p>
+            <a:pPr algn="l">
+              <a:lnSpc>
+                <a:spcPct val="115000"/>
+              </a:lnSpc>
+              <a:spcAft>
+                <a:spcPts val="0"/>
+              </a:spcAft>
+            </a:pPr>
+            <a:r>
+              <a:rPr sz="1700" b="0">
+                <a:solidFill>
+                  <a:srgbClr val="333B47"/>
+                </a:solidFill>
+                <a:latin typeface="Arial"/>
+              </a:rPr>
+              <a:t>With a risk budget ε, stop first the tasks with the </a:t>
+            </a:r>
+            <a:r>
+              <a:rPr sz="1700" b="1">
+                <a:solidFill>
+                  <a:srgbClr val="333B47"/>
+                </a:solidFill>
+                <a:latin typeface="Arial"/>
+              </a:rPr>
+              <a:t>least gain per token</a:t>
+            </a:r>
+            <a:r>
+              <a:rPr sz="1700" b="0">
+                <a:solidFill>
+                  <a:srgbClr val="333B47"/>
+                </a:solidFill>
+                <a:latin typeface="Arial"/>
+              </a:rPr>
+              <a:t>, like packing a knapsack.</a:t>
+            </a:r>
+          </a:p>
+        </p:txBody>
+      </p:sp>
+      <p:sp>
+        <p:nvSpPr>
+          <p:cNvPr id="8" name="Oval 7"/>
+          <p:cNvSpPr/>
+          <p:nvPr/>
+        </p:nvSpPr>
+        <p:spPr>
+          <a:xfrm>
+            <a:off x="812800" y="3048000"/>
+            <a:ext cx="355600" cy="355600"/>
+          </a:xfrm>
+          <a:prstGeom prst="ellipse">
+            <a:avLst/>
+          </a:prstGeom>
+          <a:solidFill>
+            <a:srgbClr val="006FCF"/>
+          </a:solidFill>
+          <a:ln>
+            <a:noFill/>
+          </a:ln>
+          <a:effectLst/>
+        </p:spPr>
+        <p:style>
+          <a:lnRef idx="1">
+            <a:schemeClr val="accent1"/>
+          </a:lnRef>
+          <a:fillRef idx="3">
+            <a:schemeClr val="accent1"/>
+          </a:fillRef>
+          <a:effectRef idx="2">
+            <a:schemeClr val="accent1"/>
+          </a:effectRef>
+          <a:fontRef idx="minor">
+            <a:schemeClr val="lt1"/>
+          </a:fontRef>
+        </p:style>
+        <p:txBody>
+          <a:bodyPr rtlCol="0" anchor="ctr" wrap="square" lIns="0" rIns="0" tIns="0" bIns="0"/>
+          <a:lstStyle/>
+          <a:p>
+            <a:pPr algn="ctr">
+              <a:lnSpc>
+                <a:spcPct val="115000"/>
+              </a:lnSpc>
+              <a:spcAft>
+                <a:spcPts val="0"/>
+              </a:spcAft>
+            </a:pPr>
+            <a:r>
+              <a:rPr sz="2400" b="1">
+                <a:solidFill>
+                  <a:srgbClr val="F6F8FB"/>
+                </a:solidFill>
+                <a:latin typeface="Arial"/>
+              </a:rPr>
+              <a:t>3</a:t>
+            </a:r>
+          </a:p>
+        </p:txBody>
+      </p:sp>
+      <p:sp>
+        <p:nvSpPr>
+          <p:cNvPr id="9" name="TextBox 8"/>
+          <p:cNvSpPr txBox="1"/>
+          <p:nvPr/>
+        </p:nvSpPr>
+        <p:spPr>
+          <a:xfrm>
+            <a:off x="1295400" y="3035300"/>
+            <a:ext cx="4826000" cy="698500"/>
+          </a:xfrm>
+          <a:prstGeom prst="rect">
+            <a:avLst/>
+          </a:prstGeom>
+          <a:noFill/>
+        </p:spPr>
+        <p:txBody>
+          <a:bodyPr wrap="square" lIns="0" rIns="0" tIns="0" bIns="0" anchor="t">
+            <a:spAutoFit/>
+          </a:bodyPr>
+          <a:lstStyle/>
+          <a:p>
+            <a:pPr algn="l">
+              <a:lnSpc>
+                <a:spcPct val="115000"/>
+              </a:lnSpc>
+              <a:spcAft>
+                <a:spcPts val="0"/>
+              </a:spcAft>
+            </a:pPr>
+            <a:r>
+              <a:rPr sz="1700" b="0">
+                <a:solidFill>
+                  <a:srgbClr val="333B47"/>
+                </a:solidFill>
+                <a:latin typeface="Arial"/>
+              </a:rPr>
+              <a:t>If gain falls as confidence rises, those are the </a:t>
+            </a:r>
+            <a:r>
+              <a:rPr sz="1700" b="1">
+                <a:solidFill>
+                  <a:srgbClr val="333B47"/>
+                </a:solidFill>
+                <a:latin typeface="Arial"/>
+              </a:rPr>
+              <a:t>most confident</a:t>
+            </a:r>
+            <a:r>
+              <a:rPr sz="1700" b="0">
+                <a:solidFill>
+                  <a:srgbClr val="333B47"/>
+                </a:solidFill>
+                <a:latin typeface="Arial"/>
+              </a:rPr>
+              <a:t> tasks.</a:t>
+            </a:r>
+          </a:p>
+        </p:txBody>
+      </p:sp>
+      <p:sp>
+        <p:nvSpPr>
+          <p:cNvPr id="10" name="TextBox 9"/>
+          <p:cNvSpPr txBox="1"/>
+          <p:nvPr/>
+        </p:nvSpPr>
+        <p:spPr>
+          <a:xfrm>
+            <a:off x="812800" y="3810000"/>
+            <a:ext cx="5207000" cy="215900"/>
+          </a:xfrm>
+          <a:prstGeom prst="rect">
+            <a:avLst/>
+          </a:prstGeom>
+          <a:noFill/>
+        </p:spPr>
+        <p:txBody>
+          <a:bodyPr wrap="square" lIns="0" rIns="0" tIns="0" bIns="0" anchor="t">
+            <a:spAutoFit/>
+          </a:bodyPr>
+          <a:lstStyle/>
+          <a:p>
+            <a:pPr algn="l">
+              <a:lnSpc>
+                <a:spcPct val="115000"/>
+              </a:lnSpc>
+              <a:spcAft>
+                <a:spcPts val="0"/>
+              </a:spcAft>
+            </a:pPr>
+            <a:r>
+              <a:rPr sz="1800" b="1">
+                <a:solidFill>
+                  <a:srgbClr val="00175A"/>
+                </a:solidFill>
+                <a:latin typeface="Arial"/>
+              </a:rPr>
+              <a:t>So the best rule:</a:t>
+            </a:r>
+          </a:p>
+        </p:txBody>
+      </p:sp>
+      <p:sp>
+        <p:nvSpPr>
+          <p:cNvPr id="11" name="Rectangle 10"/>
+          <p:cNvSpPr/>
+          <p:nvPr/>
+        </p:nvSpPr>
+        <p:spPr>
+          <a:xfrm>
+            <a:off x="812800" y="4127500"/>
+            <a:ext cx="2984500" cy="571500"/>
+          </a:xfrm>
+          <a:prstGeom prst="rect">
+            <a:avLst/>
+          </a:prstGeom>
+          <a:solidFill>
+            <a:srgbClr val="DDEDFB"/>
+          </a:solidFill>
+          <a:ln w="25400">
+            <a:solidFill>
+              <a:srgbClr val="006FCF"/>
+            </a:solidFill>
+          </a:ln>
+          <a:effectLst/>
+        </p:spPr>
+        <p:style>
+          <a:lnRef idx="1">
+            <a:schemeClr val="accent1"/>
+          </a:lnRef>
+          <a:fillRef idx="3">
+            <a:schemeClr val="accent1"/>
+          </a:fillRef>
+          <a:effectRef idx="2">
+            <a:schemeClr val="accent1"/>
+          </a:effectRef>
+          <a:fontRef idx="minor">
+            <a:schemeClr val="lt1"/>
+          </a:fontRef>
+        </p:style>
+        <p:txBody>
+          <a:bodyPr rtlCol="0" anchor="ctr" wrap="square" lIns="38100" rIns="38100" tIns="38100" bIns="38100"/>
+          <a:lstStyle/>
+          <a:p>
+            <a:pPr algn="ctr">
+              <a:lnSpc>
+                <a:spcPct val="115000"/>
+              </a:lnSpc>
+              <a:spcAft>
+                <a:spcPts val="0"/>
+              </a:spcAft>
+            </a:pPr>
+            <a:r>
+              <a:rPr sz="1800" b="1">
+                <a:solidFill>
+                  <a:srgbClr val="00175A"/>
+                </a:solidFill>
+                <a:latin typeface="Arial"/>
+              </a:rPr>
+              <a:t>below t: call the team</a:t>
+            </a:r>
+          </a:p>
+        </p:txBody>
+      </p:sp>
+      <p:sp>
+        <p:nvSpPr>
+          <p:cNvPr id="12" name="Rectangle 11"/>
+          <p:cNvSpPr/>
+          <p:nvPr/>
+        </p:nvSpPr>
+        <p:spPr>
+          <a:xfrm>
+            <a:off x="3797300" y="4127500"/>
+            <a:ext cx="2222500" cy="571500"/>
+          </a:xfrm>
+          <a:prstGeom prst="rect">
+            <a:avLst/>
+          </a:prstGeom>
+          <a:solidFill>
+            <a:srgbClr val="E3ECE2"/>
+          </a:solidFill>
+          <a:ln w="25400">
+            <a:solidFill>
+              <a:srgbClr val="2F6B34"/>
+            </a:solidFill>
+          </a:ln>
+          <a:effectLst/>
+        </p:spPr>
+        <p:style>
+          <a:lnRef idx="1">
+            <a:schemeClr val="accent1"/>
+          </a:lnRef>
+          <a:fillRef idx="3">
+            <a:schemeClr val="accent1"/>
+          </a:fillRef>
+          <a:effectRef idx="2">
+            <a:schemeClr val="accent1"/>
+          </a:effectRef>
+          <a:fontRef idx="minor">
+            <a:schemeClr val="lt1"/>
+          </a:fontRef>
+        </p:style>
+        <p:txBody>
+          <a:bodyPr rtlCol="0" anchor="ctr" wrap="square" lIns="38100" rIns="38100" tIns="38100" bIns="38100"/>
+          <a:lstStyle/>
+          <a:p>
+            <a:pPr algn="ctr">
+              <a:lnSpc>
+                <a:spcPct val="115000"/>
+              </a:lnSpc>
+              <a:spcAft>
+                <a:spcPts val="0"/>
+              </a:spcAft>
+            </a:pPr>
+            <a:r>
+              <a:rPr sz="1800" b="1">
+                <a:solidFill>
+                  <a:srgbClr val="2F6B34"/>
+                </a:solidFill>
+                <a:latin typeface="Arial"/>
+              </a:rPr>
+              <a:t>above t: stop</a:t>
+            </a:r>
+          </a:p>
+        </p:txBody>
+      </p:sp>
+      <p:sp>
+        <p:nvSpPr>
+          <p:cNvPr id="13" name="Rectangle 12"/>
+          <p:cNvSpPr/>
+          <p:nvPr/>
+        </p:nvSpPr>
+        <p:spPr>
+          <a:xfrm>
+            <a:off x="3759200" y="4000500"/>
+            <a:ext cx="76200" cy="825500"/>
+          </a:xfrm>
+          <a:prstGeom prst="rect">
+            <a:avLst/>
+          </a:prstGeom>
+          <a:solidFill>
+            <a:srgbClr val="B03A2E"/>
+          </a:solidFill>
+          <a:ln>
+            <a:noFill/>
+          </a:ln>
+          <a:effectLst/>
+        </p:spPr>
+        <p:style>
+          <a:lnRef idx="1">
+            <a:schemeClr val="accent1"/>
+          </a:lnRef>
+          <a:fillRef idx="3">
+            <a:schemeClr val="accent1"/>
+          </a:fillRef>
+          <a:effectRef idx="2">
+            <a:schemeClr val="accent1"/>
+          </a:effectRef>
+          <a:fontRef idx="minor">
+            <a:schemeClr val="lt1"/>
+          </a:fontRef>
+        </p:style>
+        <p:txBody>
+          <a:bodyPr rtlCol="0" anchor="ctr"/>
+          <a:lstStyle/>
+          <a:p>
+            <a:pPr algn="ctr"/>
+          </a:p>
+        </p:txBody>
+      </p:sp>
+      <p:sp>
+        <p:nvSpPr>
+          <p:cNvPr id="14" name="TextBox 13"/>
+          <p:cNvSpPr txBox="1"/>
+          <p:nvPr/>
+        </p:nvSpPr>
+        <p:spPr>
+          <a:xfrm>
+            <a:off x="3556000" y="4838700"/>
+            <a:ext cx="508000" cy="215900"/>
+          </a:xfrm>
+          <a:prstGeom prst="rect">
+            <a:avLst/>
+          </a:prstGeom>
+          <a:noFill/>
+        </p:spPr>
+        <p:txBody>
+          <a:bodyPr wrap="square" lIns="0" rIns="0" tIns="0" bIns="0" anchor="t">
+            <a:spAutoFit/>
+          </a:bodyPr>
+          <a:lstStyle/>
+          <a:p>
+            <a:pPr algn="ctr">
+              <a:lnSpc>
+                <a:spcPct val="115000"/>
+              </a:lnSpc>
+              <a:spcAft>
+                <a:spcPts val="0"/>
+              </a:spcAft>
+            </a:pPr>
+            <a:r>
+              <a:rPr sz="2000" b="1">
+                <a:solidFill>
+                  <a:srgbClr val="B03A2E"/>
+                </a:solidFill>
+                <a:latin typeface="Arial"/>
+              </a:rPr>
+              <a:t>t</a:t>
+            </a:r>
+          </a:p>
+        </p:txBody>
+      </p:sp>
+      <p:sp>
+        <p:nvSpPr>
+          <p:cNvPr id="15" name="TextBox 14"/>
+          <p:cNvSpPr txBox="1"/>
+          <p:nvPr/>
+        </p:nvSpPr>
+        <p:spPr>
+          <a:xfrm>
+            <a:off x="812800" y="4838700"/>
+            <a:ext cx="2540000" cy="215900"/>
+          </a:xfrm>
+          <a:prstGeom prst="rect">
+            <a:avLst/>
+          </a:prstGeom>
+          <a:noFill/>
+        </p:spPr>
+        <p:txBody>
+          <a:bodyPr wrap="square" lIns="0" rIns="0" tIns="0" bIns="0" anchor="t">
+            <a:spAutoFit/>
+          </a:bodyPr>
+          <a:lstStyle/>
+          <a:p>
+            <a:pPr algn="l">
+              <a:lnSpc>
+                <a:spcPct val="115000"/>
+              </a:lnSpc>
+              <a:spcAft>
+                <a:spcPts val="0"/>
+              </a:spcAft>
+            </a:pPr>
+            <a:r>
+              <a:rPr sz="1500" b="0">
+                <a:solidFill>
+                  <a:srgbClr val="6B7480"/>
+                </a:solidFill>
+                <a:latin typeface="Arial"/>
+              </a:rPr>
+              <a:t>low confidence</a:t>
+            </a:r>
+          </a:p>
+        </p:txBody>
+      </p:sp>
+      <p:sp>
+        <p:nvSpPr>
+          <p:cNvPr id="16" name="TextBox 15"/>
+          <p:cNvSpPr txBox="1"/>
+          <p:nvPr/>
+        </p:nvSpPr>
+        <p:spPr>
+          <a:xfrm>
+            <a:off x="4749800" y="4838700"/>
+            <a:ext cx="1270000" cy="215900"/>
+          </a:xfrm>
+          <a:prstGeom prst="rect">
+            <a:avLst/>
+          </a:prstGeom>
+          <a:noFill/>
+        </p:spPr>
+        <p:txBody>
+          <a:bodyPr wrap="square" lIns="0" rIns="0" tIns="0" bIns="0" anchor="t">
+            <a:spAutoFit/>
+          </a:bodyPr>
+          <a:lstStyle/>
+          <a:p>
+            <a:pPr algn="r">
+              <a:lnSpc>
+                <a:spcPct val="115000"/>
+              </a:lnSpc>
+              <a:spcAft>
+                <a:spcPts val="0"/>
+              </a:spcAft>
+            </a:pPr>
+            <a:r>
+              <a:rPr sz="1500" b="0">
+                <a:solidFill>
+                  <a:srgbClr val="6B7480"/>
+                </a:solidFill>
+                <a:latin typeface="Arial"/>
+              </a:rPr>
+              <a:t>high</a:t>
+            </a:r>
+          </a:p>
+        </p:txBody>
+      </p:sp>
+      <p:sp>
+        <p:nvSpPr>
+          <p:cNvPr id="17" name="TextBox 16"/>
+          <p:cNvSpPr txBox="1"/>
+          <p:nvPr/>
+        </p:nvSpPr>
+        <p:spPr>
+          <a:xfrm>
+            <a:off x="6350000" y="1524000"/>
+            <a:ext cx="5029200" cy="254000"/>
+          </a:xfrm>
+          <a:prstGeom prst="rect">
+            <a:avLst/>
+          </a:prstGeom>
+          <a:noFill/>
+        </p:spPr>
+        <p:txBody>
+          <a:bodyPr wrap="square" lIns="0" rIns="0" tIns="0" bIns="0" anchor="t">
+            <a:spAutoFit/>
+          </a:bodyPr>
+          <a:lstStyle/>
+          <a:p>
+            <a:pPr algn="l">
+              <a:lnSpc>
+                <a:spcPct val="115000"/>
+              </a:lnSpc>
+              <a:spcAft>
+                <a:spcPts val="0"/>
+              </a:spcAft>
+            </a:pPr>
+            <a:r>
+              <a:rPr sz="1800" b="1">
+                <a:solidFill>
+                  <a:srgbClr val="00175A"/>
+                </a:solidFill>
+                <a:latin typeface="Arial"/>
+              </a:rPr>
+              <a:t>Does gain fall with confidence?  Mostly</a:t>
+            </a:r>
+          </a:p>
+        </p:txBody>
+      </p:sp>
+      <p:pic>
+        <p:nvPicPr>
+          <p:cNvPr id="18" name="Picture 17" descr="c_monotone.png"/>
+          <p:cNvPicPr>
+            <a:picLocks noChangeAspect="1"/>
+          </p:cNvPicPr>
+          <p:nvPr/>
+        </p:nvPicPr>
+        <p:blipFill>
+          <a:blip r:embed="rId3"/>
+          <a:stretch>
+            <a:fillRect/>
+          </a:stretch>
+        </p:blipFill>
+        <p:spPr>
+          <a:xfrm>
+            <a:off x="6607907" y="1841500"/>
+            <a:ext cx="4564184" cy="3048000"/>
+          </a:xfrm>
+          <a:prstGeom prst="rect">
+            <a:avLst/>
+          </a:prstGeom>
+        </p:spPr>
+      </p:pic>
+      <p:sp>
+        <p:nvSpPr>
+          <p:cNvPr id="19" name="TextBox 18"/>
+          <p:cNvSpPr txBox="1"/>
+          <p:nvPr/>
+        </p:nvSpPr>
+        <p:spPr>
+          <a:xfrm>
+            <a:off x="6350000" y="4953000"/>
+            <a:ext cx="5029200" cy="444500"/>
+          </a:xfrm>
+          <a:prstGeom prst="rect">
+            <a:avLst/>
+          </a:prstGeom>
+          <a:noFill/>
+        </p:spPr>
+        <p:txBody>
+          <a:bodyPr wrap="square" lIns="0" rIns="0" tIns="0" bIns="0" anchor="t">
+            <a:spAutoFit/>
+          </a:bodyPr>
+          <a:lstStyle/>
+          <a:p>
+            <a:pPr algn="l">
+              <a:lnSpc>
+                <a:spcPct val="115000"/>
+              </a:lnSpc>
+              <a:spcAft>
+                <a:spcPts val="0"/>
+              </a:spcAft>
+            </a:pPr>
+            <a:r>
+              <a:rPr sz="1400" b="0">
+                <a:solidFill>
+                  <a:srgbClr val="6B7480"/>
+                </a:solidFill>
+                <a:latin typeface="Arial"/>
+              </a:rPr>
+              <a:t>9 settings where confidence ranks right. Falls on 8. Gemma’s 3 backwards ones excluded.</a:t>
+            </a:r>
+          </a:p>
+        </p:txBody>
+      </p:sp>
+      <p:sp>
+        <p:nvSpPr>
+          <p:cNvPr id="20" name="Rounded Rectangle 19"/>
+          <p:cNvSpPr/>
+          <p:nvPr/>
+        </p:nvSpPr>
+        <p:spPr>
+          <a:xfrm>
+            <a:off x="812800" y="5588000"/>
+            <a:ext cx="10566400" cy="571500"/>
+          </a:xfrm>
+          <a:prstGeom prst="roundRect">
+            <a:avLst>
+              <a:gd name="adj" fmla="val 10000"/>
+            </a:avLst>
+          </a:prstGeom>
+          <a:solidFill>
+            <a:srgbClr val="00175A"/>
+          </a:solidFill>
+          <a:ln>
+            <a:noFill/>
+          </a:ln>
+          <a:effectLst/>
+        </p:spPr>
+        <p:style>
+          <a:lnRef idx="1">
+            <a:schemeClr val="accent1"/>
+          </a:lnRef>
+          <a:fillRef idx="3">
+            <a:schemeClr val="accent1"/>
+          </a:fillRef>
+          <a:effectRef idx="2">
+            <a:schemeClr val="accent1"/>
+          </a:effectRef>
+          <a:fontRef idx="minor">
+            <a:schemeClr val="lt1"/>
+          </a:fontRef>
+        </p:style>
+        <p:txBody>
+          <a:bodyPr rtlCol="0" anchor="ctr" wrap="square" lIns="63500" rIns="63500" tIns="63500" bIns="63500"/>
+          <a:lstStyle/>
+          <a:p>
+            <a:pPr algn="ctr">
+              <a:lnSpc>
+                <a:spcPct val="115000"/>
+              </a:lnSpc>
+              <a:spcAft>
+                <a:spcPts val="0"/>
+              </a:spcAft>
+            </a:pPr>
+            <a:r>
+              <a:rPr sz="2000" b="0">
+                <a:solidFill>
+                  <a:srgbClr val="F6F8FB"/>
+                </a:solidFill>
+                <a:latin typeface="Arial"/>
+              </a:rPr>
+              <a:t>Theory gives the </a:t>
+            </a:r>
+            <a:r>
+              <a:rPr sz="2000" b="1">
+                <a:solidFill>
+                  <a:srgbClr val="F6F8FB"/>
+                </a:solidFill>
+                <a:latin typeface="Arial"/>
+              </a:rPr>
+              <a:t>form</a:t>
+            </a:r>
+            <a:r>
+              <a:rPr sz="2000" b="0">
+                <a:solidFill>
+                  <a:srgbClr val="F6F8FB"/>
+                </a:solidFill>
+                <a:latin typeface="Arial"/>
+              </a:rPr>
+              <a:t>: a threshold.   Where to put it: </a:t>
+            </a:r>
+            <a:r>
+              <a:rPr sz="2000" b="1">
+                <a:solidFill>
+                  <a:srgbClr val="66B2F0"/>
+                </a:solidFill>
+                <a:latin typeface="Arial"/>
+              </a:rPr>
+              <a:t>the data must decide.</a:t>
+            </a:r>
+          </a:p>
+        </p:txBody>
+      </p:sp>
+      <p:sp>
+        <p:nvSpPr>
+          <p:cNvPr id="21" name="TextBox 20"/>
+          <p:cNvSpPr txBox="1"/>
+          <p:nvPr/>
+        </p:nvSpPr>
+        <p:spPr>
+          <a:xfrm>
+            <a:off x="812800" y="6413500"/>
+            <a:ext cx="10566400" cy="215900"/>
+          </a:xfrm>
+          <a:prstGeom prst="rect">
+            <a:avLst/>
+          </a:prstGeom>
+          <a:noFill/>
+        </p:spPr>
+        <p:txBody>
+          <a:bodyPr wrap="square" lIns="0" rIns="0" tIns="0" bIns="0" anchor="t">
+            <a:spAutoFit/>
+          </a:bodyPr>
+          <a:lstStyle/>
+          <a:p>
+            <a:pPr algn="r">
+              <a:lnSpc>
+                <a:spcPct val="115000"/>
+              </a:lnSpc>
+              <a:spcAft>
+                <a:spcPts val="0"/>
+              </a:spcAft>
+            </a:pPr>
+            <a:r>
+              <a:rPr sz="1200" b="0">
+                <a:solidFill>
+                  <a:srgbClr val="6B7480"/>
+                </a:solidFill>
+                <a:latin typeface="Arial"/>
+              </a:rPr>
+              <a:t>8</a:t>
             </a:r>
           </a:p>
         </p:txBody>
@@ -24225,7 +25341,7 @@
                 </a:solidFill>
                 <a:latin typeface="Arial"/>
               </a:rPr>
-              <a:t>21</a:t>
+              <a:t>22</a:t>
             </a:r>
           </a:p>
         </p:txBody>
@@ -25660,7 +26776,7 @@
                 </a:solidFill>
                 <a:latin typeface="Arial"/>
               </a:rPr>
-              <a:t>22</a:t>
+              <a:t>23</a:t>
             </a:r>
           </a:p>
         </p:txBody>

</xml_diff>

<commit_message>
Talk: trim the threshold-optimality slide
Co-Authored-By: Claude Opus 5.5 <noreply@anthropic.com>
Claude-Session: https://claude.ai/code/session_01DzDRVWLEv7aS47cAeY8akt
</commit_message>
<xml_diff>
--- a/slides/CLIMB_talk.pptx
+++ b/slides/CLIMB_talk.pptx
@@ -23311,74 +23311,14 @@
       </p:sp>
       <p:sp>
         <p:nvSpPr>
-          <p:cNvPr id="4" name="Oval 3"/>
-          <p:cNvSpPr/>
-          <p:nvPr/>
-        </p:nvSpPr>
-        <p:spPr>
-          <a:xfrm>
-            <a:off x="812800" y="1587500"/>
-            <a:ext cx="355600" cy="355600"/>
-          </a:xfrm>
-          <a:prstGeom prst="ellipse">
-            <a:avLst/>
-          </a:prstGeom>
-          <a:solidFill>
-            <a:srgbClr val="006FCF"/>
-          </a:solidFill>
-          <a:ln>
-            <a:noFill/>
-          </a:ln>
-          <a:effectLst/>
-        </p:spPr>
-        <p:style>
-          <a:lnRef idx="1">
-            <a:schemeClr val="accent1"/>
-          </a:lnRef>
-          <a:fillRef idx="3">
-            <a:schemeClr val="accent1"/>
-          </a:fillRef>
-          <a:effectRef idx="2">
-            <a:schemeClr val="accent1"/>
-          </a:effectRef>
-          <a:fontRef idx="minor">
-            <a:schemeClr val="lt1"/>
-          </a:fontRef>
-        </p:style>
-        <p:txBody>
-          <a:bodyPr rtlCol="0" anchor="ctr" wrap="square" lIns="0" rIns="0" tIns="0" bIns="0"/>
-          <a:lstStyle/>
-          <a:p>
-            <a:pPr algn="ctr">
-              <a:lnSpc>
-                <a:spcPct val="115000"/>
-              </a:lnSpc>
-              <a:spcAft>
-                <a:spcPts val="0"/>
-              </a:spcAft>
-            </a:pPr>
-            <a:r>
-              <a:rPr sz="2400" b="1">
-                <a:solidFill>
-                  <a:srgbClr val="F6F8FB"/>
-                </a:solidFill>
-                <a:latin typeface="Arial"/>
-              </a:rPr>
-              <a:t>1</a:t>
-            </a:r>
-          </a:p>
-        </p:txBody>
-      </p:sp>
-      <p:sp>
-        <p:nvSpPr>
-          <p:cNvPr id="5" name="TextBox 4"/>
+          <p:cNvPr id="4" name="TextBox 3"/>
           <p:cNvSpPr txBox="1"/>
           <p:nvPr/>
         </p:nvSpPr>
         <p:spPr>
           <a:xfrm>
-            <a:off x="1295400" y="1574800"/>
-            <a:ext cx="4826000" cy="698500"/>
+            <a:off x="812800" y="1714500"/>
+            <a:ext cx="5207000" cy="635000"/>
           </a:xfrm>
           <a:prstGeom prst="rect">
             <a:avLst/>
@@ -23400,27 +23340,27 @@
               </a:spcAft>
             </a:pPr>
             <a:r>
-              <a:rPr sz="1700" b="0">
-                <a:solidFill>
-                  <a:srgbClr val="333B47"/>
-                </a:solidFill>
-                <a:latin typeface="Arial"/>
-              </a:rPr>
-              <a:t>Stopping a task early saves its team tokens, but risks the accuracy the team would add: its </a:t>
-            </a:r>
-            <a:r>
-              <a:rPr sz="1700" b="1">
-                <a:solidFill>
-                  <a:srgbClr val="333B47"/>
-                </a:solidFill>
-                <a:latin typeface="Arial"/>
-              </a:rPr>
-              <a:t>gain</a:t>
-            </a:r>
-            <a:r>
-              <a:rPr sz="1700" b="0">
-                <a:solidFill>
-                  <a:srgbClr val="333B47"/>
+              <a:rPr sz="2200" b="0">
+                <a:solidFill>
+                  <a:srgbClr val="00175A"/>
+                </a:solidFill>
+                <a:latin typeface="Arial"/>
+              </a:rPr>
+              <a:t>Stop the tasks where the team adds </a:t>
+            </a:r>
+            <a:r>
+              <a:rPr sz="2200" b="1">
+                <a:solidFill>
+                  <a:srgbClr val="00175A"/>
+                </a:solidFill>
+                <a:latin typeface="Arial"/>
+              </a:rPr>
+              <a:t>least</a:t>
+            </a:r>
+            <a:r>
+              <a:rPr sz="2200" b="0">
+                <a:solidFill>
+                  <a:srgbClr val="00175A"/>
                 </a:solidFill>
                 <a:latin typeface="Arial"/>
               </a:rPr>
@@ -23431,74 +23371,14 @@
       </p:sp>
       <p:sp>
         <p:nvSpPr>
-          <p:cNvPr id="6" name="Oval 5"/>
-          <p:cNvSpPr/>
-          <p:nvPr/>
-        </p:nvSpPr>
-        <p:spPr>
-          <a:xfrm>
-            <a:off x="812800" y="2317750"/>
-            <a:ext cx="355600" cy="355600"/>
-          </a:xfrm>
-          <a:prstGeom prst="ellipse">
-            <a:avLst/>
-          </a:prstGeom>
-          <a:solidFill>
-            <a:srgbClr val="006FCF"/>
-          </a:solidFill>
-          <a:ln>
-            <a:noFill/>
-          </a:ln>
-          <a:effectLst/>
-        </p:spPr>
-        <p:style>
-          <a:lnRef idx="1">
-            <a:schemeClr val="accent1"/>
-          </a:lnRef>
-          <a:fillRef idx="3">
-            <a:schemeClr val="accent1"/>
-          </a:fillRef>
-          <a:effectRef idx="2">
-            <a:schemeClr val="accent1"/>
-          </a:effectRef>
-          <a:fontRef idx="minor">
-            <a:schemeClr val="lt1"/>
-          </a:fontRef>
-        </p:style>
-        <p:txBody>
-          <a:bodyPr rtlCol="0" anchor="ctr" wrap="square" lIns="0" rIns="0" tIns="0" bIns="0"/>
-          <a:lstStyle/>
-          <a:p>
-            <a:pPr algn="ctr">
-              <a:lnSpc>
-                <a:spcPct val="115000"/>
-              </a:lnSpc>
-              <a:spcAft>
-                <a:spcPts val="0"/>
-              </a:spcAft>
-            </a:pPr>
-            <a:r>
-              <a:rPr sz="2400" b="1">
-                <a:solidFill>
-                  <a:srgbClr val="F6F8FB"/>
-                </a:solidFill>
-                <a:latin typeface="Arial"/>
-              </a:rPr>
-              <a:t>2</a:t>
-            </a:r>
-          </a:p>
-        </p:txBody>
-      </p:sp>
-      <p:sp>
-        <p:nvSpPr>
-          <p:cNvPr id="7" name="TextBox 6"/>
+          <p:cNvPr id="5" name="TextBox 4"/>
           <p:cNvSpPr txBox="1"/>
           <p:nvPr/>
         </p:nvSpPr>
         <p:spPr>
           <a:xfrm>
-            <a:off x="1295400" y="2305050"/>
-            <a:ext cx="4826000" cy="698500"/>
+            <a:off x="812800" y="2540000"/>
+            <a:ext cx="5207000" cy="635000"/>
           </a:xfrm>
           <a:prstGeom prst="rect">
             <a:avLst/>
@@ -23520,105 +23400,45 @@
               </a:spcAft>
             </a:pPr>
             <a:r>
-              <a:rPr sz="1700" b="0">
-                <a:solidFill>
-                  <a:srgbClr val="333B47"/>
-                </a:solidFill>
-                <a:latin typeface="Arial"/>
-              </a:rPr>
-              <a:t>With a risk budget ε, stop first the tasks with the </a:t>
-            </a:r>
-            <a:r>
-              <a:rPr sz="1700" b="1">
-                <a:solidFill>
-                  <a:srgbClr val="333B47"/>
-                </a:solidFill>
-                <a:latin typeface="Arial"/>
-              </a:rPr>
-              <a:t>least gain per token</a:t>
-            </a:r>
-            <a:r>
-              <a:rPr sz="1700" b="0">
-                <a:solidFill>
-                  <a:srgbClr val="333B47"/>
-                </a:solidFill>
-                <a:latin typeface="Arial"/>
-              </a:rPr>
-              <a:t>, like packing a knapsack.</a:t>
-            </a:r>
-          </a:p>
-        </p:txBody>
-      </p:sp>
-      <p:sp>
-        <p:nvSpPr>
-          <p:cNvPr id="8" name="Oval 7"/>
-          <p:cNvSpPr/>
-          <p:nvPr/>
-        </p:nvSpPr>
-        <p:spPr>
-          <a:xfrm>
-            <a:off x="812800" y="3048000"/>
-            <a:ext cx="355600" cy="355600"/>
-          </a:xfrm>
-          <a:prstGeom prst="ellipse">
-            <a:avLst/>
-          </a:prstGeom>
-          <a:solidFill>
-            <a:srgbClr val="006FCF"/>
-          </a:solidFill>
-          <a:ln>
-            <a:noFill/>
-          </a:ln>
-          <a:effectLst/>
-        </p:spPr>
-        <p:style>
-          <a:lnRef idx="1">
-            <a:schemeClr val="accent1"/>
-          </a:lnRef>
-          <a:fillRef idx="3">
-            <a:schemeClr val="accent1"/>
-          </a:fillRef>
-          <a:effectRef idx="2">
-            <a:schemeClr val="accent1"/>
-          </a:effectRef>
-          <a:fontRef idx="minor">
-            <a:schemeClr val="lt1"/>
-          </a:fontRef>
-        </p:style>
-        <p:txBody>
-          <a:bodyPr rtlCol="0" anchor="ctr" wrap="square" lIns="0" rIns="0" tIns="0" bIns="0"/>
-          <a:lstStyle/>
-          <a:p>
-            <a:pPr algn="ctr">
-              <a:lnSpc>
-                <a:spcPct val="115000"/>
-              </a:lnSpc>
-              <a:spcAft>
-                <a:spcPts val="0"/>
-              </a:spcAft>
-            </a:pPr>
-            <a:r>
-              <a:rPr sz="2400" b="1">
-                <a:solidFill>
-                  <a:srgbClr val="F6F8FB"/>
-                </a:solidFill>
-                <a:latin typeface="Arial"/>
-              </a:rPr>
-              <a:t>3</a:t>
-            </a:r>
-          </a:p>
-        </p:txBody>
-      </p:sp>
-      <p:sp>
-        <p:nvSpPr>
-          <p:cNvPr id="9" name="TextBox 8"/>
+              <a:rPr sz="2200" b="0">
+                <a:solidFill>
+                  <a:srgbClr val="00175A"/>
+                </a:solidFill>
+                <a:latin typeface="Arial"/>
+              </a:rPr>
+              <a:t>The team adds least where confidence is </a:t>
+            </a:r>
+            <a:r>
+              <a:rPr sz="2200" b="1">
+                <a:solidFill>
+                  <a:srgbClr val="00175A"/>
+                </a:solidFill>
+                <a:latin typeface="Arial"/>
+              </a:rPr>
+              <a:t>high</a:t>
+            </a:r>
+            <a:r>
+              <a:rPr sz="2200" b="0">
+                <a:solidFill>
+                  <a:srgbClr val="00175A"/>
+                </a:solidFill>
+                <a:latin typeface="Arial"/>
+              </a:rPr>
+              <a:t>.</a:t>
+            </a:r>
+          </a:p>
+        </p:txBody>
+      </p:sp>
+      <p:sp>
+        <p:nvSpPr>
+          <p:cNvPr id="6" name="TextBox 5"/>
           <p:cNvSpPr txBox="1"/>
           <p:nvPr/>
         </p:nvSpPr>
         <p:spPr>
           <a:xfrm>
-            <a:off x="1295400" y="3035300"/>
-            <a:ext cx="4826000" cy="698500"/>
+            <a:off x="812800" y="3556000"/>
+            <a:ext cx="5207000" cy="254000"/>
           </a:xfrm>
           <a:prstGeom prst="rect">
             <a:avLst/>
@@ -23640,87 +23460,27 @@
               </a:spcAft>
             </a:pPr>
             <a:r>
-              <a:rPr sz="1700" b="0">
-                <a:solidFill>
-                  <a:srgbClr val="333B47"/>
-                </a:solidFill>
-                <a:latin typeface="Arial"/>
-              </a:rPr>
-              <a:t>If gain falls as confidence rises, those are the </a:t>
-            </a:r>
-            <a:r>
-              <a:rPr sz="1700" b="1">
-                <a:solidFill>
-                  <a:srgbClr val="333B47"/>
-                </a:solidFill>
-                <a:latin typeface="Arial"/>
-              </a:rPr>
-              <a:t>most confident</a:t>
-            </a:r>
-            <a:r>
-              <a:rPr sz="1700" b="0">
-                <a:solidFill>
-                  <a:srgbClr val="333B47"/>
-                </a:solidFill>
-                <a:latin typeface="Arial"/>
-              </a:rPr>
-              <a:t> tasks.</a:t>
-            </a:r>
-          </a:p>
-        </p:txBody>
-      </p:sp>
-      <p:sp>
-        <p:nvSpPr>
-          <p:cNvPr id="10" name="TextBox 9"/>
-          <p:cNvSpPr txBox="1"/>
-          <p:nvPr/>
-        </p:nvSpPr>
-        <p:spPr>
-          <a:xfrm>
-            <a:off x="812800" y="3810000"/>
-            <a:ext cx="5207000" cy="215900"/>
-          </a:xfrm>
-          <a:prstGeom prst="rect">
-            <a:avLst/>
-          </a:prstGeom>
-          <a:noFill/>
-        </p:spPr>
-        <p:txBody>
-          <a:bodyPr wrap="square" lIns="0" rIns="0" tIns="0" bIns="0" anchor="t">
-            <a:spAutoFit/>
-          </a:bodyPr>
-          <a:lstStyle/>
-          <a:p>
-            <a:pPr algn="l">
-              <a:lnSpc>
-                <a:spcPct val="115000"/>
-              </a:lnSpc>
-              <a:spcAft>
-                <a:spcPts val="0"/>
-              </a:spcAft>
-            </a:pPr>
-            <a:r>
-              <a:rPr sz="1800" b="1">
-                <a:solidFill>
-                  <a:srgbClr val="00175A"/>
-                </a:solidFill>
-                <a:latin typeface="Arial"/>
-              </a:rPr>
-              <a:t>So the best rule:</a:t>
-            </a:r>
-          </a:p>
-        </p:txBody>
-      </p:sp>
-      <p:sp>
-        <p:nvSpPr>
-          <p:cNvPr id="11" name="Rectangle 10"/>
+              <a:rPr sz="2000" b="1">
+                <a:solidFill>
+                  <a:srgbClr val="006FCF"/>
+                </a:solidFill>
+                <a:latin typeface="Arial"/>
+              </a:rPr>
+              <a:t>So the best rule is a threshold:</a:t>
+            </a:r>
+          </a:p>
+        </p:txBody>
+      </p:sp>
+      <p:sp>
+        <p:nvSpPr>
+          <p:cNvPr id="7" name="Rectangle 6"/>
           <p:cNvSpPr/>
           <p:nvPr/>
         </p:nvSpPr>
         <p:spPr>
           <a:xfrm>
-            <a:off x="812800" y="4127500"/>
-            <a:ext cx="2984500" cy="571500"/>
+            <a:off x="812800" y="3937000"/>
+            <a:ext cx="2984500" cy="635000"/>
           </a:xfrm>
           <a:prstGeom prst="rect">
             <a:avLst/>
@@ -23762,7 +23522,7 @@
               </a:spcAft>
             </a:pPr>
             <a:r>
-              <a:rPr sz="1800" b="1">
+              <a:rPr sz="2000" b="1">
                 <a:solidFill>
                   <a:srgbClr val="00175A"/>
                 </a:solidFill>
@@ -23775,14 +23535,14 @@
       </p:sp>
       <p:sp>
         <p:nvSpPr>
-          <p:cNvPr id="12" name="Rectangle 11"/>
+          <p:cNvPr id="8" name="Rectangle 7"/>
           <p:cNvSpPr/>
           <p:nvPr/>
         </p:nvSpPr>
         <p:spPr>
           <a:xfrm>
-            <a:off x="3797300" y="4127500"/>
-            <a:ext cx="2222500" cy="571500"/>
+            <a:off x="3797300" y="3937000"/>
+            <a:ext cx="2222500" cy="635000"/>
           </a:xfrm>
           <a:prstGeom prst="rect">
             <a:avLst/>
@@ -23824,7 +23584,7 @@
               </a:spcAft>
             </a:pPr>
             <a:r>
-              <a:rPr sz="1800" b="1">
+              <a:rPr sz="2000" b="1">
                 <a:solidFill>
                   <a:srgbClr val="2F6B34"/>
                 </a:solidFill>
@@ -23837,14 +23597,14 @@
       </p:sp>
       <p:sp>
         <p:nvSpPr>
-          <p:cNvPr id="13" name="Rectangle 12"/>
+          <p:cNvPr id="9" name="Rectangle 8"/>
           <p:cNvSpPr/>
           <p:nvPr/>
         </p:nvSpPr>
         <p:spPr>
           <a:xfrm>
-            <a:off x="3759200" y="4000500"/>
-            <a:ext cx="76200" cy="825500"/>
+            <a:off x="3759200" y="3810000"/>
+            <a:ext cx="76200" cy="889000"/>
           </a:xfrm>
           <a:prstGeom prst="rect">
             <a:avLst/>
@@ -23881,13 +23641,13 @@
       </p:sp>
       <p:sp>
         <p:nvSpPr>
-          <p:cNvPr id="14" name="TextBox 13"/>
+          <p:cNvPr id="10" name="TextBox 9"/>
           <p:cNvSpPr txBox="1"/>
           <p:nvPr/>
         </p:nvSpPr>
         <p:spPr>
           <a:xfrm>
-            <a:off x="3556000" y="4838700"/>
+            <a:off x="3556000" y="4730750"/>
             <a:ext cx="508000" cy="215900"/>
           </a:xfrm>
           <a:prstGeom prst="rect">
@@ -23910,7 +23670,7 @@
               </a:spcAft>
             </a:pPr>
             <a:r>
-              <a:rPr sz="2000" b="1">
+              <a:rPr sz="2200" b="1">
                 <a:solidFill>
                   <a:srgbClr val="B03A2E"/>
                 </a:solidFill>
@@ -23923,13 +23683,13 @@
       </p:sp>
       <p:sp>
         <p:nvSpPr>
-          <p:cNvPr id="15" name="TextBox 14"/>
+          <p:cNvPr id="11" name="TextBox 10"/>
           <p:cNvSpPr txBox="1"/>
           <p:nvPr/>
         </p:nvSpPr>
         <p:spPr>
           <a:xfrm>
-            <a:off x="812800" y="4838700"/>
+            <a:off x="812800" y="4730750"/>
             <a:ext cx="2540000" cy="215900"/>
           </a:xfrm>
           <a:prstGeom prst="rect">
@@ -23952,7 +23712,7 @@
               </a:spcAft>
             </a:pPr>
             <a:r>
-              <a:rPr sz="1500" b="0">
+              <a:rPr sz="1600" b="0">
                 <a:solidFill>
                   <a:srgbClr val="6B7480"/>
                 </a:solidFill>
@@ -23965,13 +23725,13 @@
       </p:sp>
       <p:sp>
         <p:nvSpPr>
-          <p:cNvPr id="16" name="TextBox 15"/>
+          <p:cNvPr id="12" name="TextBox 11"/>
           <p:cNvSpPr txBox="1"/>
           <p:nvPr/>
         </p:nvSpPr>
         <p:spPr>
           <a:xfrm>
-            <a:off x="4749800" y="4838700"/>
+            <a:off x="4749800" y="4730750"/>
             <a:ext cx="1270000" cy="215900"/>
           </a:xfrm>
           <a:prstGeom prst="rect">
@@ -23994,7 +23754,7 @@
               </a:spcAft>
             </a:pPr>
             <a:r>
-              <a:rPr sz="1500" b="0">
+              <a:rPr sz="1600" b="0">
                 <a:solidFill>
                   <a:srgbClr val="6B7480"/>
                 </a:solidFill>
@@ -24007,7 +23767,7 @@
       </p:sp>
       <p:sp>
         <p:nvSpPr>
-          <p:cNvPr id="17" name="TextBox 16"/>
+          <p:cNvPr id="13" name="TextBox 12"/>
           <p:cNvSpPr txBox="1"/>
           <p:nvPr/>
         </p:nvSpPr>
@@ -24036,20 +23796,20 @@
               </a:spcAft>
             </a:pPr>
             <a:r>
-              <a:rPr sz="1800" b="1">
+              <a:rPr sz="2000" b="1">
                 <a:solidFill>
                   <a:srgbClr val="00175A"/>
                 </a:solidFill>
                 <a:latin typeface="Arial"/>
               </a:rPr>
-              <a:t>Does gain fall with confidence?  Mostly</a:t>
+              <a:t>Gain from the team, by confidence</a:t>
             </a:r>
           </a:p>
         </p:txBody>
       </p:sp>
       <p:pic>
         <p:nvPicPr>
-          <p:cNvPr id="18" name="Picture 17" descr="c_monotone.png"/>
+          <p:cNvPr id="14" name="Picture 13" descr="c_monotone.png"/>
           <p:cNvPicPr>
             <a:picLocks noChangeAspect="1"/>
           </p:cNvPicPr>
@@ -24063,8 +23823,8 @@
         </p:blipFill>
         <p:spPr>
           <a:xfrm>
-            <a:off x="6607907" y="1841500"/>
-            <a:ext cx="4564184" cy="3048000"/>
+            <a:off x="6354298" y="1968500"/>
+            <a:ext cx="5020603" cy="3352800"/>
           </a:xfrm>
           <a:prstGeom prst="rect">
             <a:avLst/>
@@ -24073,55 +23833,13 @@
       </p:pic>
       <p:sp>
         <p:nvSpPr>
-          <p:cNvPr id="19" name="TextBox 18"/>
-          <p:cNvSpPr txBox="1"/>
-          <p:nvPr/>
-        </p:nvSpPr>
-        <p:spPr>
-          <a:xfrm>
-            <a:off x="6350000" y="4953000"/>
-            <a:ext cx="5029200" cy="444500"/>
-          </a:xfrm>
-          <a:prstGeom prst="rect">
-            <a:avLst/>
-          </a:prstGeom>
-          <a:noFill/>
-        </p:spPr>
-        <p:txBody>
-          <a:bodyPr wrap="square" lIns="0" rIns="0" tIns="0" bIns="0" anchor="t">
-            <a:spAutoFit/>
-          </a:bodyPr>
-          <a:lstStyle/>
-          <a:p>
-            <a:pPr algn="l">
-              <a:lnSpc>
-                <a:spcPct val="115000"/>
-              </a:lnSpc>
-              <a:spcAft>
-                <a:spcPts val="0"/>
-              </a:spcAft>
-            </a:pPr>
-            <a:r>
-              <a:rPr sz="1400" b="0">
-                <a:solidFill>
-                  <a:srgbClr val="6B7480"/>
-                </a:solidFill>
-                <a:latin typeface="Arial"/>
-              </a:rPr>
-              <a:t>9 settings where confidence ranks right. Falls on 8. Gemma’s 3 backwards ones excluded.</a:t>
-            </a:r>
-          </a:p>
-        </p:txBody>
-      </p:sp>
-      <p:sp>
-        <p:nvSpPr>
-          <p:cNvPr id="20" name="Rounded Rectangle 19"/>
+          <p:cNvPr id="15" name="Rounded Rectangle 14"/>
           <p:cNvSpPr/>
           <p:nvPr/>
         </p:nvSpPr>
         <p:spPr>
           <a:xfrm>
-            <a:off x="812800" y="5588000"/>
+            <a:off x="812800" y="5524500"/>
             <a:ext cx="10566400" cy="571500"/>
           </a:xfrm>
           <a:prstGeom prst="roundRect">
@@ -24164,7 +23882,7 @@
               </a:spcAft>
             </a:pPr>
             <a:r>
-              <a:rPr sz="2000" b="0">
+              <a:rPr sz="2200" b="0">
                 <a:solidFill>
                   <a:srgbClr val="F6F8FB"/>
                 </a:solidFill>
@@ -24173,7 +23891,7 @@
               <a:t>Theory gives the </a:t>
             </a:r>
             <a:r>
-              <a:rPr sz="2000" b="1">
+              <a:rPr sz="2200" b="1">
                 <a:solidFill>
                   <a:srgbClr val="F6F8FB"/>
                 </a:solidFill>
@@ -24182,29 +23900,29 @@
               <a:t>form</a:t>
             </a:r>
             <a:r>
-              <a:rPr sz="2000" b="0">
+              <a:rPr sz="2200" b="0">
                 <a:solidFill>
                   <a:srgbClr val="F6F8FB"/>
                 </a:solidFill>
                 <a:latin typeface="Arial"/>
               </a:rPr>
-              <a:t>: a threshold.   Where to put it: </a:t>
-            </a:r>
-            <a:r>
-              <a:rPr sz="2000" b="1">
+              <a:t>.  </a:t>
+            </a:r>
+            <a:r>
+              <a:rPr sz="2200" b="1">
                 <a:solidFill>
                   <a:srgbClr val="66B2F0"/>
                 </a:solidFill>
                 <a:latin typeface="Arial"/>
               </a:rPr>
-              <a:t>the data must decide.</a:t>
-            </a:r>
-          </a:p>
-        </p:txBody>
-      </p:sp>
-      <p:sp>
-        <p:nvSpPr>
-          <p:cNvPr id="21" name="TextBox 20"/>
+              <a:t>The data decides where t goes.</a:t>
+            </a:r>
+          </a:p>
+        </p:txBody>
+      </p:sp>
+      <p:sp>
+        <p:nvSpPr>
+          <p:cNvPr id="16" name="TextBox 15"/>
           <p:cNvSpPr txBox="1"/>
           <p:nvPr/>
         </p:nvSpPr>

</xml_diff>

<commit_message>
Talk: link the $20 bound to the certified set, add an accuracy comparison slide
Co-Authored-By: Claude Opus 5.5 <noreply@anthropic.com>
Claude-Session: https://claude.ai/code/session_01DzDRVWLEv7aS47cAeY8akt
</commit_message>
<xml_diff>
--- a/slides/CLIMB_talk.pptx
+++ b/slides/CLIMB_talk.pptx
@@ -22,6 +22,7 @@
     <p:sldId id="285" r:id="rId37"/>
     <p:sldId id="271" r:id="rId23"/>
     <p:sldId id="277" r:id="rId29"/>
+    <p:sldId id="287" r:id="rId39"/>
     <p:sldId id="279" r:id="rId31"/>
     <p:sldId id="280" r:id="rId32"/>
     <p:sldId id="281" r:id="rId33"/>
@@ -882,7 +883,7 @@
           <a:lstStyle/>
           <a:p>
             <a:r>
-              <a:t>Why should reaching 20 convince us? Suppose the threshold is actually unsafe, so it loses more than the tolerance. Then every bet loses money on average, so the gambler's average wealth stays at most one dollar. His money can never go negative. If he reached 20 dollars more than 1 time in 20, those cases alone would push his average above one dollar. That is impossible. So an unsafe threshold passes at most 5 percent of the time. Twenty is just one over five percent. Stopping as soon as he reaches 20 is covered too: freeze the money there and the same argument holds. We check two families of rules, each at 5 percent, so 90 percent overall. A pass means we accept the threshold and are wrong at most 5 percent of the time, like a driving test: passing gets you a licence, it does not prove you can drive.</a:t>
+              <a:t>Why should reaching 20 convince us? Suppose the threshold is actually unsafe, so it loses more than the tolerance. Then every bet loses money on average, so the gambler's average wealth stays at most one dollar. His money can never go negative. If he reached 20 dollars more than 1 time in 20, those cases alone would push his average above one dollar. That is impossible. So an unsafe threshold passes at most 5 percent of the time. Twenty is just one over five percent. Stopping as soon as he reaches 20 is covered too: freeze the money there and the same argument holds. How do we get from one test to a threshold we can use? We test the thresholds in a fixed order, strict to loose, and stop at the first failure. Every threshold before that failure is certified. An unsafe threshold can only end up certified if the first unsafe threshold in the order passed its own test, and that happens at most 5 percent of the time. So with one 5 percent budget, every certified threshold is safe with probability at least 95 percent, and we deploy the cheapest of them. We do not need to split the 5 percent across thresholds. We check two families of rules, each at 5 percent, so 90 percent overall. A pass means we accept the threshold and are wrong at most 5 percent of the time, like a driving test: passing gets you a licence, it does not prove you can drive.</a:t>
             </a:r>
           </a:p>
         </p:txBody>
@@ -2213,6 +2214,76 @@
           <a:p>
             <a:r>
               <a:t>Why is the rule a threshold, and not something more complex? Think of it as packing a bag. Stopping a task early saves the team's tokens on it, but risks the accuracy the team would have added, its gain. You can afford a total risk of epsilon. To save the most tokens, you stop first the tasks with the least gain per token saved, exactly like a knapsack. Now, if the gain falls as confidence rises, those are the most confident tasks. So the best rule stops every task above some confidence, and escalates the rest: a threshold. The paper proves this as a proposition. Does the gain fall with confidence? On the right, the gain from calling the team in each fifth of tasks, on the nine settings where confidence ranks answers the right way. It falls from 17 points on the least confident fifth to 4 to 6 on the confident ones, and it falls on eight of the nine. On Gemma's three backwards settings it does not, and there the guarantee still holds, the savings come from agreement. So theory gives the form of the rule. What it cannot give is where the line goes: that depends on the unknown gain, and the data has to decide.</a:t>
+            </a:r>
+          </a:p>
+        </p:txBody>
+      </p:sp>
+      <p:sp>
+        <p:nvSpPr>
+          <p:cNvPr id="4" name="Slide Number Placeholder 3"/>
+          <p:cNvSpPr>
+            <a:spLocks noGrp="1"/>
+          </p:cNvSpPr>
+          <p:nvPr>
+            <p:ph type="sldNum" idx="5" sz="quarter"/>
+          </p:nvPr>
+        </p:nvSpPr>
+        <p:spPr/>
+      </p:sp>
+    </p:spTree>
+  </p:cSld>
+  <p:clrMapOvr>
+    <a:masterClrMapping/>
+  </p:clrMapOvr>
+</p:notes>
+</file>
+
+<file path=ppt/notesSlides/notesSlide32.xml><?xml version="1.0" encoding="utf-8"?>
+<p:notes xmlns:a="http://schemas.openxmlformats.org/drawingml/2006/main" xmlns:p="http://schemas.openxmlformats.org/presentationml/2006/main" xmlns:r="http://schemas.openxmlformats.org/officeDocument/2006/relationships">
+  <p:cSld>
+    <p:spTree>
+      <p:nvGrpSpPr>
+        <p:cNvPr id="1" name=""/>
+        <p:cNvGrpSpPr/>
+        <p:nvPr/>
+      </p:nvGrpSpPr>
+      <p:grpSpPr>
+        <a:xfrm>
+          <a:off x="0" y="0"/>
+          <a:ext cx="0" cy="0"/>
+          <a:chOff x="0" y="0"/>
+          <a:chExt cx="0" cy="0"/>
+        </a:xfrm>
+      </p:grpSpPr>
+      <p:sp>
+        <p:nvSpPr>
+          <p:cNvPr id="2" name="Slide Image Placeholder 1"/>
+          <p:cNvSpPr>
+            <a:spLocks noGrp="1"/>
+          </p:cNvSpPr>
+          <p:nvPr>
+            <p:ph type="sldImg" idx="2"/>
+          </p:nvPr>
+        </p:nvSpPr>
+        <p:spPr/>
+      </p:sp>
+      <p:sp>
+        <p:nvSpPr>
+          <p:cNvPr id="3" name="Notes Placeholder 2"/>
+          <p:cNvSpPr>
+            <a:spLocks noGrp="1"/>
+          </p:cNvSpPr>
+          <p:nvPr>
+            <p:ph type="body" idx="3" sz="quarter"/>
+          </p:nvPr>
+        </p:nvSpPr>
+        <p:spPr/>
+        <p:txBody>
+          <a:bodyPr/>
+          <a:lstStyle/>
+          <a:p>
+            <a:r>
+              <a:t>Does CLIMB really stay inside the loss we allowed? Here is the accuracy itself. Left: always calling the team, in orange, against CLIMB at a 5 point tolerance, in green, on each of the 12 settings. The bars are close. Right: how many points CLIMB loses against the team, averaged over 200 random splits. Allowed 5 points, it loses between 1.1 and 2.8. Allowed 10, between 1.8 and 7.2. Every bar sits below its line. These are averages. Single splits can go above the line, and the previous slide counted how often: at most 2 percent of splits, against the 10 percent the guarantee allows.</a:t>
             </a:r>
           </a:p>
         </p:txBody>
@@ -6154,7 +6225,7 @@
                 </a:solidFill>
                 <a:latin typeface="Arial"/>
               </a:rPr>
-              <a:t>24</a:t>
+              <a:t>25</a:t>
             </a:r>
           </a:p>
         </p:txBody>
@@ -8774,12 +8845,12 @@
         </p:nvSpPr>
         <p:spPr>
           <a:xfrm>
-            <a:off x="812800" y="1778000"/>
-            <a:ext cx="3111500" cy="1397000"/>
+            <a:off x="812800" y="1651000"/>
+            <a:ext cx="3111500" cy="952500"/>
           </a:xfrm>
           <a:prstGeom prst="roundRect">
             <a:avLst>
-              <a:gd name="adj" fmla="val 8181"/>
+              <a:gd name="adj" fmla="val 10000"/>
             </a:avLst>
           </a:prstGeom>
           <a:solidFill>
@@ -8807,7 +8878,7 @@
           </a:fontRef>
         </p:style>
         <p:txBody>
-          <a:bodyPr rtlCol="0" anchor="ctr" wrap="square" lIns="139700" rIns="139700" tIns="139700" bIns="139700"/>
+          <a:bodyPr rtlCol="0" anchor="ctr" wrap="square" lIns="101600" rIns="101600" tIns="101600" bIns="101600"/>
           <a:lstStyle/>
           <a:p>
             <a:pPr algn="ctr">
@@ -8815,11 +8886,11 @@
                 <a:spcPct val="115000"/>
               </a:lnSpc>
               <a:spcAft>
-                <a:spcPts val="1000"/>
-              </a:spcAft>
-            </a:pPr>
-            <a:r>
-              <a:rPr sz="2600" b="1">
+                <a:spcPts val="600"/>
+              </a:spcAft>
+            </a:pPr>
+            <a:r>
+              <a:rPr sz="2400" b="1">
                 <a:solidFill>
                   <a:srgbClr val="B03A2E"/>
                 </a:solidFill>
@@ -8838,7 +8909,7 @@
               </a:spcAft>
             </a:pPr>
             <a:r>
-              <a:rPr sz="1800" b="0">
+              <a:rPr sz="1700" b="0">
                 <a:solidFill>
                   <a:srgbClr val="333B47"/>
                 </a:solidFill>
@@ -8857,7 +8928,7 @@
         </p:nvSpPr>
         <p:spPr>
           <a:xfrm>
-            <a:off x="3987800" y="2317750"/>
+            <a:off x="3987800" y="1968500"/>
             <a:ext cx="419100" cy="317500"/>
           </a:xfrm>
           <a:prstGeom prst="rightArrow">
@@ -8901,12 +8972,12 @@
         </p:nvSpPr>
         <p:spPr>
           <a:xfrm>
-            <a:off x="4464050" y="1778000"/>
-            <a:ext cx="3111500" cy="1397000"/>
+            <a:off x="4464050" y="1651000"/>
+            <a:ext cx="3111500" cy="952500"/>
           </a:xfrm>
           <a:prstGeom prst="roundRect">
             <a:avLst>
-              <a:gd name="adj" fmla="val 8181"/>
+              <a:gd name="adj" fmla="val 10000"/>
             </a:avLst>
           </a:prstGeom>
           <a:solidFill>
@@ -8934,7 +9005,7 @@
           </a:fontRef>
         </p:style>
         <p:txBody>
-          <a:bodyPr rtlCol="0" anchor="ctr" wrap="square" lIns="139700" rIns="139700" tIns="139700" bIns="139700"/>
+          <a:bodyPr rtlCol="0" anchor="ctr" wrap="square" lIns="101600" rIns="101600" tIns="101600" bIns="101600"/>
           <a:lstStyle/>
           <a:p>
             <a:pPr algn="ctr">
@@ -8942,11 +9013,11 @@
                 <a:spcPct val="115000"/>
               </a:lnSpc>
               <a:spcAft>
-                <a:spcPts val="1000"/>
-              </a:spcAft>
-            </a:pPr>
-            <a:r>
-              <a:rPr sz="2600" b="1">
+                <a:spcPts val="600"/>
+              </a:spcAft>
+            </a:pPr>
+            <a:r>
+              <a:rPr sz="2400" b="1">
                 <a:solidFill>
                   <a:srgbClr val="00175A"/>
                 </a:solidFill>
@@ -8965,13 +9036,13 @@
               </a:spcAft>
             </a:pPr>
             <a:r>
-              <a:rPr sz="1800" b="0">
+              <a:rPr sz="1700" b="0">
                 <a:solidFill>
                   <a:srgbClr val="333B47"/>
                 </a:solidFill>
                 <a:latin typeface="Arial"/>
               </a:rPr>
-              <a:t>starts at $1, never grows on average</a:t>
+              <a:t>never grows on average</a:t>
             </a:r>
           </a:p>
         </p:txBody>
@@ -8984,7 +9055,7 @@
         </p:nvSpPr>
         <p:spPr>
           <a:xfrm>
-            <a:off x="7639050" y="2317750"/>
+            <a:off x="7639050" y="1968500"/>
             <a:ext cx="419100" cy="317500"/>
           </a:xfrm>
           <a:prstGeom prst="rightArrow">
@@ -9028,12 +9099,12 @@
         </p:nvSpPr>
         <p:spPr>
           <a:xfrm>
-            <a:off x="8115300" y="1778000"/>
-            <a:ext cx="3111500" cy="1397000"/>
+            <a:off x="8115300" y="1651000"/>
+            <a:ext cx="3111500" cy="952500"/>
           </a:xfrm>
           <a:prstGeom prst="roundRect">
             <a:avLst>
-              <a:gd name="adj" fmla="val 8181"/>
+              <a:gd name="adj" fmla="val 10000"/>
             </a:avLst>
           </a:prstGeom>
           <a:solidFill>
@@ -9061,7 +9132,7 @@
           </a:fontRef>
         </p:style>
         <p:txBody>
-          <a:bodyPr rtlCol="0" anchor="ctr" wrap="square" lIns="139700" rIns="139700" tIns="139700" bIns="139700"/>
+          <a:bodyPr rtlCol="0" anchor="ctr" wrap="square" lIns="101600" rIns="101600" tIns="101600" bIns="101600"/>
           <a:lstStyle/>
           <a:p>
             <a:pPr algn="ctr">
@@ -9069,11 +9140,11 @@
                 <a:spcPct val="115000"/>
               </a:lnSpc>
               <a:spcAft>
-                <a:spcPts val="1000"/>
-              </a:spcAft>
-            </a:pPr>
-            <a:r>
-              <a:rPr sz="2600" b="1">
+                <a:spcPts val="600"/>
+              </a:spcAft>
+            </a:pPr>
+            <a:r>
+              <a:rPr sz="2400" b="1">
                 <a:solidFill>
                   <a:srgbClr val="00175A"/>
                 </a:solidFill>
@@ -9092,13 +9163,13 @@
               </a:spcAft>
             </a:pPr>
             <a:r>
-              <a:rPr sz="1800" b="0">
+              <a:rPr sz="1700" b="0">
                 <a:solidFill>
                   <a:srgbClr val="333B47"/>
                 </a:solidFill>
                 <a:latin typeface="Arial"/>
               </a:rPr>
-              <a:t>a lost answer at most halves it</a:t>
+              <a:t>a loss at most halves it</a:t>
             </a:r>
           </a:p>
         </p:txBody>
@@ -9111,12 +9182,12 @@
         </p:nvSpPr>
         <p:spPr>
           <a:xfrm>
-            <a:off x="812800" y="3492500"/>
-            <a:ext cx="10566400" cy="1270000"/>
+            <a:off x="812800" y="2794000"/>
+            <a:ext cx="10566400" cy="952500"/>
           </a:xfrm>
           <a:prstGeom prst="roundRect">
             <a:avLst>
-              <a:gd name="adj" fmla="val 9000"/>
+              <a:gd name="adj" fmla="val 10000"/>
             </a:avLst>
           </a:prstGeom>
           <a:solidFill>
@@ -9142,7 +9213,7 @@
           </a:fontRef>
         </p:style>
         <p:txBody>
-          <a:bodyPr rtlCol="0" anchor="ctr" wrap="square" lIns="127000" rIns="127000" tIns="127000" bIns="127000"/>
+          <a:bodyPr rtlCol="0" anchor="ctr" wrap="square" lIns="88900" rIns="88900" tIns="88900" bIns="88900"/>
           <a:lstStyle/>
           <a:p>
             <a:pPr algn="ctr">
@@ -9150,11 +9221,11 @@
                 <a:spcPct val="115000"/>
               </a:lnSpc>
               <a:spcAft>
-                <a:spcPts val="1000"/>
-              </a:spcAft>
-            </a:pPr>
-            <a:r>
-              <a:rPr sz="3600" b="1">
+                <a:spcPts val="600"/>
+              </a:spcAft>
+            </a:pPr>
+            <a:r>
+              <a:rPr sz="3000" b="1">
                 <a:solidFill>
                   <a:srgbClr val="F6F8FB"/>
                 </a:solidFill>
@@ -9173,7 +9244,7 @@
               </a:spcAft>
             </a:pPr>
             <a:r>
-              <a:rPr sz="2800" b="1">
+              <a:rPr sz="2400" b="1">
                 <a:solidFill>
                   <a:srgbClr val="F6F8FB"/>
                 </a:solidFill>
@@ -9182,7 +9253,7 @@
               <a:t>so  </a:t>
             </a:r>
             <a:r>
-              <a:rPr sz="2800" b="1">
+              <a:rPr sz="2400" b="1">
                 <a:solidFill>
                   <a:srgbClr val="66B2F0"/>
                 </a:solidFill>
@@ -9195,26 +9266,68 @@
       </p:sp>
       <p:sp>
         <p:nvSpPr>
-          <p:cNvPr id="10" name="Rounded Rectangle 9"/>
+          <p:cNvPr id="10" name="TextBox 9"/>
+          <p:cNvSpPr txBox="1"/>
+          <p:nvPr/>
+        </p:nvSpPr>
+        <p:spPr>
+          <a:xfrm>
+            <a:off x="812800" y="3886200"/>
+            <a:ext cx="10566400" cy="254000"/>
+          </a:xfrm>
+          <a:prstGeom prst="rect">
+            <a:avLst/>
+          </a:prstGeom>
+          <a:noFill/>
+        </p:spPr>
+        <p:txBody>
+          <a:bodyPr wrap="square" lIns="0" rIns="0" tIns="0" bIns="0" anchor="t">
+            <a:spAutoFit/>
+          </a:bodyPr>
+          <a:lstStyle/>
+          <a:p>
+            <a:pPr algn="l">
+              <a:lnSpc>
+                <a:spcPct val="115000"/>
+              </a:lnSpc>
+              <a:spcAft>
+                <a:spcPts val="0"/>
+              </a:spcAft>
+            </a:pPr>
+            <a:r>
+              <a:rPr sz="2000" b="1">
+                <a:solidFill>
+                  <a:srgbClr val="006FCF"/>
+                </a:solidFill>
+                <a:latin typeface="Arial"/>
+              </a:rPr>
+              <a:t>From one test to a threshold we can deploy</a:t>
+            </a:r>
+          </a:p>
+        </p:txBody>
+      </p:sp>
+      <p:sp>
+        <p:nvSpPr>
+          <p:cNvPr id="11" name="Rounded Rectangle 10"/>
           <p:cNvSpPr/>
           <p:nvPr/>
         </p:nvSpPr>
         <p:spPr>
           <a:xfrm>
-            <a:off x="812800" y="5016500"/>
-            <a:ext cx="5080000" cy="1143000"/>
+            <a:off x="812800" y="4254500"/>
+            <a:ext cx="3111500" cy="1841500"/>
           </a:xfrm>
           <a:prstGeom prst="roundRect">
             <a:avLst>
-              <a:gd name="adj" fmla="val 10000"/>
+              <a:gd name="adj" fmla="val 6206"/>
             </a:avLst>
           </a:prstGeom>
           <a:solidFill>
-            <a:srgbClr val="FFFFFF"/>
+            <a:srgbClr val="E9EEF5"/>
           </a:solidFill>
-          <a:ln w="12700">
+          <a:ln w="31750">
             <a:solidFill>
-              <a:srgbClr val="D3DCE8"/>
+              <a:srgbClr val="00175A"/>
             </a:solidFill>
           </a:ln>
           <a:effectLst/>
@@ -9234,29 +9347,29 @@
           </a:fontRef>
         </p:style>
         <p:txBody>
-          <a:bodyPr rtlCol="0" anchor="ctr" wrap="square" lIns="152400" rIns="152400" tIns="152400" bIns="152400"/>
-          <a:lstStyle/>
-          <a:p>
-            <a:pPr algn="l">
-              <a:lnSpc>
-                <a:spcPct val="115000"/>
-              </a:lnSpc>
-              <a:spcAft>
-                <a:spcPts val="600"/>
-              </a:spcAft>
-            </a:pPr>
-            <a:r>
-              <a:rPr sz="2000" b="1">
+          <a:bodyPr rtlCol="0" anchor="ctr" wrap="square" lIns="127000" rIns="127000" tIns="127000" bIns="127000"/>
+          <a:lstStyle/>
+          <a:p>
+            <a:pPr algn="ctr">
+              <a:lnSpc>
+                <a:spcPct val="115000"/>
+              </a:lnSpc>
+              <a:spcAft>
+                <a:spcPts val="1000"/>
+              </a:spcAft>
+            </a:pPr>
+            <a:r>
+              <a:rPr sz="2400" b="1">
                 <a:solidFill>
                   <a:srgbClr val="00175A"/>
                 </a:solidFill>
                 <a:latin typeface="Arial"/>
               </a:rPr>
-              <a:t>100 worlds, $100 in total</a:t>
-            </a:r>
-          </a:p>
-          <a:p>
-            <a:pPr algn="l">
+              <a:t>One threshold</a:t>
+            </a:r>
+          </a:p>
+          <a:p>
+            <a:pPr algn="ctr">
               <a:lnSpc>
                 <a:spcPct val="115000"/>
               </a:lnSpc>
@@ -9267,38 +9380,34 @@
             <a:r>
               <a:rPr sz="1800" b="0">
                 <a:solidFill>
-                  <a:srgbClr val="6B7480"/>
-                </a:solidFill>
-                <a:latin typeface="Arial"/>
-              </a:rPr>
-              <a:t>Each pass holds $20, so at most 5 of 100 pass. $100 line → 1%.</a:t>
-            </a:r>
-          </a:p>
-        </p:txBody>
-      </p:sp>
-      <p:sp>
-        <p:nvSpPr>
-          <p:cNvPr id="11" name="Rounded Rectangle 10"/>
+                  <a:srgbClr val="333B47"/>
+                </a:solidFill>
+                <a:latin typeface="Arial"/>
+              </a:rPr>
+              <a:t>An unsafe one passes ≤ 5%.</a:t>
+            </a:r>
+          </a:p>
+        </p:txBody>
+      </p:sp>
+      <p:sp>
+        <p:nvSpPr>
+          <p:cNvPr id="12" name="Right Arrow 11"/>
           <p:cNvSpPr/>
           <p:nvPr/>
         </p:nvSpPr>
         <p:spPr>
           <a:xfrm>
-            <a:off x="6299200" y="5016500"/>
-            <a:ext cx="5080000" cy="1143000"/>
-          </a:xfrm>
-          <a:prstGeom prst="roundRect">
-            <a:avLst>
-              <a:gd name="adj" fmla="val 10000"/>
-            </a:avLst>
+            <a:off x="3987800" y="5016500"/>
+            <a:ext cx="419100" cy="317500"/>
+          </a:xfrm>
+          <a:prstGeom prst="rightArrow">
+            <a:avLst/>
           </a:prstGeom>
           <a:solidFill>
-            <a:srgbClr val="FFFFFF"/>
+            <a:srgbClr val="6B7480"/>
           </a:solidFill>
-          <a:ln w="12700">
-            <a:solidFill>
-              <a:srgbClr val="D3DCE8"/>
-            </a:solidFill>
+          <a:ln>
+            <a:noFill/>
           </a:ln>
           <a:effectLst/>
         </p:spPr>
@@ -9317,29 +9426,77 @@
           </a:fontRef>
         </p:style>
         <p:txBody>
-          <a:bodyPr rtlCol="0" anchor="ctr" wrap="square" lIns="152400" rIns="152400" tIns="152400" bIns="152400"/>
-          <a:lstStyle/>
-          <a:p>
-            <a:pPr algn="l">
-              <a:lnSpc>
-                <a:spcPct val="115000"/>
-              </a:lnSpc>
-              <a:spcAft>
-                <a:spcPts val="600"/>
-              </a:spcAft>
-            </a:pPr>
-            <a:r>
-              <a:rPr sz="2000" b="1">
+          <a:bodyPr rtlCol="0" anchor="ctr"/>
+          <a:lstStyle/>
+          <a:p>
+            <a:pPr algn="ctr"/>
+          </a:p>
+        </p:txBody>
+      </p:sp>
+      <p:sp>
+        <p:nvSpPr>
+          <p:cNvPr id="13" name="Rounded Rectangle 12"/>
+          <p:cNvSpPr/>
+          <p:nvPr/>
+        </p:nvSpPr>
+        <p:spPr>
+          <a:xfrm>
+            <a:off x="4464050" y="4254500"/>
+            <a:ext cx="3111500" cy="1841500"/>
+          </a:xfrm>
+          <a:prstGeom prst="roundRect">
+            <a:avLst>
+              <a:gd name="adj" fmla="val 6206"/>
+            </a:avLst>
+          </a:prstGeom>
+          <a:solidFill>
+            <a:srgbClr val="E9EEF5"/>
+          </a:solidFill>
+          <a:ln w="31750">
+            <a:solidFill>
+              <a:srgbClr val="00175A"/>
+            </a:solidFill>
+          </a:ln>
+          <a:effectLst/>
+        </p:spPr>
+        <p:style>
+          <a:lnRef idx="1">
+            <a:schemeClr val="accent1"/>
+          </a:lnRef>
+          <a:fillRef idx="3">
+            <a:schemeClr val="accent1"/>
+          </a:fillRef>
+          <a:effectRef idx="2">
+            <a:schemeClr val="accent1"/>
+          </a:effectRef>
+          <a:fontRef idx="minor">
+            <a:schemeClr val="lt1"/>
+          </a:fontRef>
+        </p:style>
+        <p:txBody>
+          <a:bodyPr rtlCol="0" anchor="ctr" wrap="square" lIns="127000" rIns="127000" tIns="127000" bIns="127000"/>
+          <a:lstStyle/>
+          <a:p>
+            <a:pPr algn="ctr">
+              <a:lnSpc>
+                <a:spcPct val="115000"/>
+              </a:lnSpc>
+              <a:spcAft>
+                <a:spcPts val="1000"/>
+              </a:spcAft>
+            </a:pPr>
+            <a:r>
+              <a:rPr sz="2400" b="1">
                 <a:solidFill>
                   <a:srgbClr val="00175A"/>
                 </a:solidFill>
                 <a:latin typeface="Arial"/>
               </a:rPr>
-              <a:t>A pass: accept, wrong ≤ 5% of the time</a:t>
-            </a:r>
-          </a:p>
-          <a:p>
-            <a:pPr algn="l">
+              <a:t>Strict → loose</a:t>
+            </a:r>
+          </a:p>
+          <a:p>
+            <a:pPr algn="ctr">
               <a:lnSpc>
                 <a:spcPct val="115000"/>
               </a:lnSpc>
@@ -9350,18 +9507,163 @@
             <a:r>
               <a:rPr sz="1800" b="0">
                 <a:solidFill>
-                  <a:srgbClr val="6B7480"/>
-                </a:solidFill>
-                <a:latin typeface="Arial"/>
-              </a:rPr>
-              <a:t>Like a driving test, not proof you can drive.</a:t>
-            </a:r>
-          </a:p>
-        </p:txBody>
-      </p:sp>
-      <p:sp>
-        <p:nvSpPr>
-          <p:cNvPr id="12" name="TextBox 11"/>
+                  <a:srgbClr val="333B47"/>
+                </a:solidFill>
+                <a:latin typeface="Arial"/>
+              </a:rPr>
+              <a:t>Stop at the first failure.  An unsafe one gets in only if the </a:t>
+            </a:r>
+            <a:r>
+              <a:rPr sz="1800" b="1">
+                <a:solidFill>
+                  <a:srgbClr val="333B47"/>
+                </a:solidFill>
+                <a:latin typeface="Arial"/>
+              </a:rPr>
+              <a:t>first</a:t>
+            </a:r>
+            <a:r>
+              <a:rPr sz="1800" b="0">
+                <a:solidFill>
+                  <a:srgbClr val="333B47"/>
+                </a:solidFill>
+                <a:latin typeface="Arial"/>
+              </a:rPr>
+              <a:t> unsafe one passes: ≤ 5%.</a:t>
+            </a:r>
+          </a:p>
+        </p:txBody>
+      </p:sp>
+      <p:sp>
+        <p:nvSpPr>
+          <p:cNvPr id="14" name="Right Arrow 13"/>
+          <p:cNvSpPr/>
+          <p:nvPr/>
+        </p:nvSpPr>
+        <p:spPr>
+          <a:xfrm>
+            <a:off x="7639050" y="5016500"/>
+            <a:ext cx="419100" cy="317500"/>
+          </a:xfrm>
+          <a:prstGeom prst="rightArrow">
+            <a:avLst/>
+          </a:prstGeom>
+          <a:solidFill>
+            <a:srgbClr val="6B7480"/>
+          </a:solidFill>
+          <a:ln>
+            <a:noFill/>
+          </a:ln>
+          <a:effectLst/>
+        </p:spPr>
+        <p:style>
+          <a:lnRef idx="1">
+            <a:schemeClr val="accent1"/>
+          </a:lnRef>
+          <a:fillRef idx="3">
+            <a:schemeClr val="accent1"/>
+          </a:fillRef>
+          <a:effectRef idx="2">
+            <a:schemeClr val="accent1"/>
+          </a:effectRef>
+          <a:fontRef idx="minor">
+            <a:schemeClr val="lt1"/>
+          </a:fontRef>
+        </p:style>
+        <p:txBody>
+          <a:bodyPr rtlCol="0" anchor="ctr"/>
+          <a:lstStyle/>
+          <a:p>
+            <a:pPr algn="ctr"/>
+          </a:p>
+        </p:txBody>
+      </p:sp>
+      <p:sp>
+        <p:nvSpPr>
+          <p:cNvPr id="15" name="Rounded Rectangle 14"/>
+          <p:cNvSpPr/>
+          <p:nvPr/>
+        </p:nvSpPr>
+        <p:spPr>
+          <a:xfrm>
+            <a:off x="8115300" y="4254500"/>
+            <a:ext cx="3111500" cy="1841500"/>
+          </a:xfrm>
+          <a:prstGeom prst="roundRect">
+            <a:avLst>
+              <a:gd name="adj" fmla="val 6206"/>
+            </a:avLst>
+          </a:prstGeom>
+          <a:solidFill>
+            <a:srgbClr val="E3ECE2"/>
+          </a:solidFill>
+          <a:ln w="31750">
+            <a:solidFill>
+              <a:srgbClr val="2F6B34"/>
+            </a:solidFill>
+          </a:ln>
+          <a:effectLst/>
+        </p:spPr>
+        <p:style>
+          <a:lnRef idx="1">
+            <a:schemeClr val="accent1"/>
+          </a:lnRef>
+          <a:fillRef idx="3">
+            <a:schemeClr val="accent1"/>
+          </a:fillRef>
+          <a:effectRef idx="2">
+            <a:schemeClr val="accent1"/>
+          </a:effectRef>
+          <a:fontRef idx="minor">
+            <a:schemeClr val="lt1"/>
+          </a:fontRef>
+        </p:style>
+        <p:txBody>
+          <a:bodyPr rtlCol="0" anchor="ctr" wrap="square" lIns="127000" rIns="127000" tIns="127000" bIns="127000"/>
+          <a:lstStyle/>
+          <a:p>
+            <a:pPr algn="ctr">
+              <a:lnSpc>
+                <a:spcPct val="115000"/>
+              </a:lnSpc>
+              <a:spcAft>
+                <a:spcPts val="1000"/>
+              </a:spcAft>
+            </a:pPr>
+            <a:r>
+              <a:rPr sz="2400" b="1">
+                <a:solidFill>
+                  <a:srgbClr val="2F6B34"/>
+                </a:solidFill>
+                <a:latin typeface="Arial"/>
+              </a:rPr>
+              <a:t>Certified set</a:t>
+            </a:r>
+          </a:p>
+          <a:p>
+            <a:pPr algn="ctr">
+              <a:lnSpc>
+                <a:spcPct val="115000"/>
+              </a:lnSpc>
+              <a:spcAft>
+                <a:spcPts val="0"/>
+              </a:spcAft>
+            </a:pPr>
+            <a:r>
+              <a:rPr sz="1800" b="0">
+                <a:solidFill>
+                  <a:srgbClr val="333B47"/>
+                </a:solidFill>
+                <a:latin typeface="Arial"/>
+              </a:rPr>
+              <a:t>All safe with prob. ≥ 95%.  ★ Deploy the cheapest.</a:t>
+            </a:r>
+          </a:p>
+        </p:txBody>
+      </p:sp>
+      <p:sp>
+        <p:nvSpPr>
+          <p:cNvPr id="16" name="TextBox 15"/>
           <p:cNvSpPr txBox="1"/>
           <p:nvPr/>
         </p:nvSpPr>
@@ -9970,7 +10272,7 @@
                 </a:solidFill>
                 <a:latin typeface="Arial"/>
               </a:rPr>
-              <a:t>26</a:t>
+              <a:t>27</a:t>
             </a:r>
           </a:p>
         </p:txBody>
@@ -10531,7 +10833,7 @@
                 </a:solidFill>
                 <a:latin typeface="Arial"/>
               </a:rPr>
-              <a:t>27</a:t>
+              <a:t>28</a:t>
             </a:r>
           </a:p>
         </p:txBody>
@@ -11295,7 +11597,7 @@
                 </a:solidFill>
                 <a:latin typeface="Arial"/>
               </a:rPr>
-              <a:t>28</a:t>
+              <a:t>29</a:t>
             </a:r>
           </a:p>
         </p:txBody>
@@ -12893,7 +13195,7 @@
                 </a:solidFill>
                 <a:latin typeface="Arial"/>
               </a:rPr>
-              <a:t>29</a:t>
+              <a:t>30</a:t>
             </a:r>
           </a:p>
         </p:txBody>
@@ -14409,7 +14711,7 @@
                 </a:solidFill>
                 <a:latin typeface="Arial"/>
               </a:rPr>
-              <a:t>30</a:t>
+              <a:t>31</a:t>
             </a:r>
           </a:p>
         </p:txBody>
@@ -14751,7 +15053,7 @@
                 </a:solidFill>
                 <a:latin typeface="Arial"/>
               </a:rPr>
-              <a:t>31</a:t>
+              <a:t>32</a:t>
             </a:r>
           </a:p>
         </p:txBody>
@@ -15460,7 +15762,7 @@
                 </a:solidFill>
                 <a:latin typeface="Arial"/>
               </a:rPr>
-              <a:t>25</a:t>
+              <a:t>26</a:t>
             </a:r>
           </a:p>
         </p:txBody>
@@ -15969,7 +16271,7 @@
                 </a:solidFill>
                 <a:latin typeface="Arial"/>
               </a:rPr>
-              <a:t>18</a:t>
+              <a:t>19</a:t>
             </a:r>
           </a:p>
         </p:txBody>
@@ -17241,7 +17543,7 @@
                 </a:solidFill>
                 <a:latin typeface="Arial"/>
               </a:rPr>
-              <a:t>19</a:t>
+              <a:t>20</a:t>
             </a:r>
           </a:p>
         </p:txBody>
@@ -17393,7 +17695,7 @@
                 </a:solidFill>
                 <a:latin typeface="Arial"/>
               </a:rPr>
-              <a:t>20</a:t>
+              <a:t>21</a:t>
             </a:r>
           </a:p>
         </p:txBody>
@@ -19821,7 +20123,7 @@
                 </a:solidFill>
                 <a:latin typeface="Arial"/>
               </a:rPr>
-              <a:t>21</a:t>
+              <a:t>22</a:t>
             </a:r>
           </a:p>
         </p:txBody>
@@ -23970,6 +24272,456 @@
 </p:sld>
 </file>
 
+<file path=ppt/slides/slide32.xml><?xml version="1.0" encoding="utf-8"?>
+<p:sld xmlns:a="http://schemas.openxmlformats.org/drawingml/2006/main" xmlns:p="http://schemas.openxmlformats.org/presentationml/2006/main" xmlns:r="http://schemas.openxmlformats.org/officeDocument/2006/relationships">
+  <p:cSld>
+    <p:bg>
+      <p:bgPr>
+        <a:solidFill>
+          <a:srgbClr val="F6F8FB"/>
+        </a:solidFill>
+        <a:effectLst/>
+      </p:bgPr>
+    </p:bg>
+    <p:spTree>
+      <p:nvGrpSpPr>
+        <p:cNvPr id="1" name=""/>
+        <p:cNvGrpSpPr/>
+        <p:nvPr/>
+      </p:nvGrpSpPr>
+      <p:grpSpPr/>
+      <p:sp>
+        <p:nvSpPr>
+          <p:cNvPr id="2" name="TextBox 1"/>
+          <p:cNvSpPr txBox="1"/>
+          <p:nvPr/>
+        </p:nvSpPr>
+        <p:spPr>
+          <a:xfrm>
+            <a:off x="812800" y="635000"/>
+            <a:ext cx="10566400" cy="254000"/>
+          </a:xfrm>
+          <a:prstGeom prst="rect">
+            <a:avLst/>
+          </a:prstGeom>
+          <a:noFill/>
+        </p:spPr>
+        <p:txBody>
+          <a:bodyPr wrap="square" lIns="0" rIns="0" tIns="0" bIns="0" anchor="t">
+            <a:spAutoFit/>
+          </a:bodyPr>
+          <a:lstStyle/>
+          <a:p>
+            <a:pPr algn="l">
+              <a:lnSpc>
+                <a:spcPct val="115000"/>
+              </a:lnSpc>
+              <a:spcAft>
+                <a:spcPts val="0"/>
+              </a:spcAft>
+            </a:pPr>
+            <a:r>
+              <a:rPr sz="1300" b="1">
+                <a:solidFill>
+                  <a:srgbClr val="006FCF"/>
+                </a:solidFill>
+                <a:latin typeface="Arial"/>
+              </a:rPr>
+              <a:t>RESULTS · 3 MODELS × 4 BENCHMARKS, 200 RANDOM SPLITS</a:t>
+            </a:r>
+          </a:p>
+        </p:txBody>
+      </p:sp>
+      <p:sp>
+        <p:nvSpPr>
+          <p:cNvPr id="3" name="TextBox 2"/>
+          <p:cNvSpPr txBox="1"/>
+          <p:nvPr/>
+        </p:nvSpPr>
+        <p:spPr>
+          <a:xfrm>
+            <a:off x="812800" y="889000"/>
+            <a:ext cx="10566400" cy="571500"/>
+          </a:xfrm>
+          <a:prstGeom prst="rect">
+            <a:avLst/>
+          </a:prstGeom>
+          <a:noFill/>
+        </p:spPr>
+        <p:txBody>
+          <a:bodyPr wrap="square" lIns="0" rIns="0" tIns="0" bIns="0" anchor="t">
+            <a:spAutoFit/>
+          </a:bodyPr>
+          <a:lstStyle/>
+          <a:p>
+            <a:pPr algn="l">
+              <a:lnSpc>
+                <a:spcPct val="105000"/>
+              </a:lnSpc>
+              <a:spcAft>
+                <a:spcPts val="0"/>
+              </a:spcAft>
+            </a:pPr>
+            <a:r>
+              <a:rPr sz="3000" b="1">
+                <a:solidFill>
+                  <a:srgbClr val="00175A"/>
+                </a:solidFill>
+                <a:latin typeface="Georgia"/>
+              </a:rPr>
+              <a:t>Accuracy with CLIMB stays within the loss you allow</a:t>
+            </a:r>
+          </a:p>
+        </p:txBody>
+      </p:sp>
+      <p:sp>
+        <p:nvSpPr>
+          <p:cNvPr id="4" name="TextBox 3"/>
+          <p:cNvSpPr txBox="1"/>
+          <p:nvPr/>
+        </p:nvSpPr>
+        <p:spPr>
+          <a:xfrm>
+            <a:off x="812800" y="1587500"/>
+            <a:ext cx="5080000" cy="254000"/>
+          </a:xfrm>
+          <a:prstGeom prst="rect">
+            <a:avLst/>
+          </a:prstGeom>
+          <a:noFill/>
+        </p:spPr>
+        <p:txBody>
+          <a:bodyPr wrap="square" lIns="0" rIns="0" tIns="0" bIns="0" anchor="t">
+            <a:spAutoFit/>
+          </a:bodyPr>
+          <a:lstStyle/>
+          <a:p>
+            <a:pPr algn="l">
+              <a:lnSpc>
+                <a:spcPct val="115000"/>
+              </a:lnSpc>
+              <a:spcAft>
+                <a:spcPts val="0"/>
+              </a:spcAft>
+            </a:pPr>
+            <a:r>
+              <a:rPr sz="2200" b="1">
+                <a:solidFill>
+                  <a:srgbClr val="00175A"/>
+                </a:solidFill>
+                <a:latin typeface="Arial"/>
+              </a:rPr>
+              <a:t>Accuracy (%)</a:t>
+            </a:r>
+          </a:p>
+        </p:txBody>
+      </p:sp>
+      <p:pic>
+        <p:nvPicPr>
+          <p:cNvPr id="5" name="Picture 4" descr="c_acccmp.png"/>
+          <p:cNvPicPr>
+            <a:picLocks noChangeAspect="1"/>
+          </p:cNvPicPr>
+          <p:nvPr/>
+        </p:nvPicPr>
+        <p:blipFill>
+          <a:blip r:embed="rId3"/>
+          <a:stretch>
+            <a:fillRect/>
+          </a:stretch>
+        </p:blipFill>
+        <p:spPr>
+          <a:xfrm>
+            <a:off x="812800" y="1996955"/>
+            <a:ext cx="5080000" cy="2610088"/>
+          </a:xfrm>
+          <a:prstGeom prst="rect">
+            <a:avLst/>
+          </a:prstGeom>
+        </p:spPr>
+      </p:pic>
+      <p:sp>
+        <p:nvSpPr>
+          <p:cNvPr id="6" name="TextBox 5"/>
+          <p:cNvSpPr txBox="1"/>
+          <p:nvPr/>
+        </p:nvSpPr>
+        <p:spPr>
+          <a:xfrm>
+            <a:off x="6299200" y="1587500"/>
+            <a:ext cx="5080000" cy="254000"/>
+          </a:xfrm>
+          <a:prstGeom prst="rect">
+            <a:avLst/>
+          </a:prstGeom>
+          <a:noFill/>
+        </p:spPr>
+        <p:txBody>
+          <a:bodyPr wrap="square" lIns="0" rIns="0" tIns="0" bIns="0" anchor="t">
+            <a:spAutoFit/>
+          </a:bodyPr>
+          <a:lstStyle/>
+          <a:p>
+            <a:pPr algn="l">
+              <a:lnSpc>
+                <a:spcPct val="115000"/>
+              </a:lnSpc>
+              <a:spcAft>
+                <a:spcPts val="0"/>
+              </a:spcAft>
+            </a:pPr>
+            <a:r>
+              <a:rPr sz="2200" b="1">
+                <a:solidFill>
+                  <a:srgbClr val="00175A"/>
+                </a:solidFill>
+                <a:latin typeface="Arial"/>
+              </a:rPr>
+              <a:t>Points lost vs always calling the team</a:t>
+            </a:r>
+          </a:p>
+        </p:txBody>
+      </p:sp>
+      <p:pic>
+        <p:nvPicPr>
+          <p:cNvPr id="7" name="Picture 6" descr="c_drop.png"/>
+          <p:cNvPicPr>
+            <a:picLocks noChangeAspect="1"/>
+          </p:cNvPicPr>
+          <p:nvPr/>
+        </p:nvPicPr>
+        <p:blipFill>
+          <a:blip r:embed="rId4"/>
+          <a:stretch>
+            <a:fillRect/>
+          </a:stretch>
+        </p:blipFill>
+        <p:spPr>
+          <a:xfrm>
+            <a:off x="6299200" y="2021685"/>
+            <a:ext cx="5080000" cy="2560628"/>
+          </a:xfrm>
+          <a:prstGeom prst="rect">
+            <a:avLst/>
+          </a:prstGeom>
+        </p:spPr>
+      </p:pic>
+      <p:sp>
+        <p:nvSpPr>
+          <p:cNvPr id="8" name="Rounded Rectangle 7"/>
+          <p:cNvSpPr/>
+          <p:nvPr/>
+        </p:nvSpPr>
+        <p:spPr>
+          <a:xfrm>
+            <a:off x="812800" y="4826000"/>
+            <a:ext cx="5080000" cy="1270000"/>
+          </a:xfrm>
+          <a:prstGeom prst="roundRect">
+            <a:avLst>
+              <a:gd name="adj" fmla="val 9000"/>
+            </a:avLst>
+          </a:prstGeom>
+          <a:solidFill>
+            <a:srgbClr val="E3ECE2"/>
+          </a:solidFill>
+          <a:ln w="12700">
+            <a:solidFill>
+              <a:srgbClr val="D3DCE8"/>
+            </a:solidFill>
+          </a:ln>
+          <a:effectLst/>
+        </p:spPr>
+        <p:style>
+          <a:lnRef idx="1">
+            <a:schemeClr val="accent1"/>
+          </a:lnRef>
+          <a:fillRef idx="3">
+            <a:schemeClr val="accent1"/>
+          </a:fillRef>
+          <a:effectRef idx="2">
+            <a:schemeClr val="accent1"/>
+          </a:effectRef>
+          <a:fontRef idx="minor">
+            <a:schemeClr val="lt1"/>
+          </a:fontRef>
+        </p:style>
+        <p:txBody>
+          <a:bodyPr rtlCol="0" anchor="ctr" wrap="square" lIns="190500" rIns="190500" tIns="190500" bIns="190500"/>
+          <a:lstStyle/>
+          <a:p>
+            <a:pPr algn="l">
+              <a:lnSpc>
+                <a:spcPct val="100000"/>
+              </a:lnSpc>
+              <a:spcAft>
+                <a:spcPts val="600"/>
+              </a:spcAft>
+            </a:pPr>
+            <a:r>
+              <a:rPr sz="3600" b="1">
+                <a:solidFill>
+                  <a:srgbClr val="2F6B34"/>
+                </a:solidFill>
+                <a:latin typeface="Georgia"/>
+              </a:rPr>
+              <a:t>1.1–2.8 points lost</a:t>
+            </a:r>
+          </a:p>
+          <a:p>
+            <a:pPr algn="l">
+              <a:lnSpc>
+                <a:spcPct val="115000"/>
+              </a:lnSpc>
+              <a:spcAft>
+                <a:spcPts val="0"/>
+              </a:spcAft>
+            </a:pPr>
+            <a:r>
+              <a:rPr sz="1700" b="0">
+                <a:solidFill>
+                  <a:srgbClr val="333B47"/>
+                </a:solidFill>
+                <a:latin typeface="Arial"/>
+              </a:rPr>
+              <a:t>allowed 5, on average over splits</a:t>
+            </a:r>
+          </a:p>
+        </p:txBody>
+      </p:sp>
+      <p:sp>
+        <p:nvSpPr>
+          <p:cNvPr id="9" name="Rounded Rectangle 8"/>
+          <p:cNvSpPr/>
+          <p:nvPr/>
+        </p:nvSpPr>
+        <p:spPr>
+          <a:xfrm>
+            <a:off x="6299200" y="4826000"/>
+            <a:ext cx="5080000" cy="1270000"/>
+          </a:xfrm>
+          <a:prstGeom prst="roundRect">
+            <a:avLst>
+              <a:gd name="adj" fmla="val 9000"/>
+            </a:avLst>
+          </a:prstGeom>
+          <a:solidFill>
+            <a:srgbClr val="E6EBF4"/>
+          </a:solidFill>
+          <a:ln w="12700">
+            <a:solidFill>
+              <a:srgbClr val="D3DCE8"/>
+            </a:solidFill>
+          </a:ln>
+          <a:effectLst/>
+        </p:spPr>
+        <p:style>
+          <a:lnRef idx="1">
+            <a:schemeClr val="accent1"/>
+          </a:lnRef>
+          <a:fillRef idx="3">
+            <a:schemeClr val="accent1"/>
+          </a:fillRef>
+          <a:effectRef idx="2">
+            <a:schemeClr val="accent1"/>
+          </a:effectRef>
+          <a:fontRef idx="minor">
+            <a:schemeClr val="lt1"/>
+          </a:fontRef>
+        </p:style>
+        <p:txBody>
+          <a:bodyPr rtlCol="0" anchor="ctr" wrap="square" lIns="190500" rIns="190500" tIns="190500" bIns="190500"/>
+          <a:lstStyle/>
+          <a:p>
+            <a:pPr algn="l">
+              <a:lnSpc>
+                <a:spcPct val="100000"/>
+              </a:lnSpc>
+              <a:spcAft>
+                <a:spcPts val="600"/>
+              </a:spcAft>
+            </a:pPr>
+            <a:r>
+              <a:rPr sz="3600" b="1">
+                <a:solidFill>
+                  <a:srgbClr val="00175A"/>
+                </a:solidFill>
+                <a:latin typeface="Georgia"/>
+              </a:rPr>
+              <a:t>1.8–7.2 points lost</a:t>
+            </a:r>
+          </a:p>
+          <a:p>
+            <a:pPr algn="l">
+              <a:lnSpc>
+                <a:spcPct val="115000"/>
+              </a:lnSpc>
+              <a:spcAft>
+                <a:spcPts val="0"/>
+              </a:spcAft>
+            </a:pPr>
+            <a:r>
+              <a:rPr sz="1700" b="0">
+                <a:solidFill>
+                  <a:srgbClr val="333B47"/>
+                </a:solidFill>
+                <a:latin typeface="Arial"/>
+              </a:rPr>
+              <a:t>allowed 10, on average over splits</a:t>
+            </a:r>
+          </a:p>
+        </p:txBody>
+      </p:sp>
+      <p:sp>
+        <p:nvSpPr>
+          <p:cNvPr id="10" name="TextBox 9"/>
+          <p:cNvSpPr txBox="1"/>
+          <p:nvPr/>
+        </p:nvSpPr>
+        <p:spPr>
+          <a:xfrm>
+            <a:off x="812800" y="6413500"/>
+            <a:ext cx="10566400" cy="215900"/>
+          </a:xfrm>
+          <a:prstGeom prst="rect">
+            <a:avLst/>
+          </a:prstGeom>
+          <a:noFill/>
+        </p:spPr>
+        <p:txBody>
+          <a:bodyPr wrap="square" lIns="0" rIns="0" tIns="0" bIns="0" anchor="t">
+            <a:spAutoFit/>
+          </a:bodyPr>
+          <a:lstStyle/>
+          <a:p>
+            <a:pPr algn="r">
+              <a:lnSpc>
+                <a:spcPct val="115000"/>
+              </a:lnSpc>
+              <a:spcAft>
+                <a:spcPts val="0"/>
+              </a:spcAft>
+            </a:pPr>
+            <a:r>
+              <a:rPr sz="1200" b="0">
+                <a:solidFill>
+                  <a:srgbClr val="6B7480"/>
+                </a:solidFill>
+                <a:latin typeface="Arial"/>
+              </a:rPr>
+              <a:t>18</a:t>
+            </a:r>
+          </a:p>
+        </p:txBody>
+      </p:sp>
+    </p:spTree>
+  </p:cSld>
+  <p:clrMapOvr>
+    <a:masterClrMapping/>
+  </p:clrMapOvr>
+</p:sld>
+</file>
+
 <file path=ppt/slides/slide4.xml><?xml version="1.0" encoding="utf-8"?>
 <p:sld xmlns:a="http://schemas.openxmlformats.org/drawingml/2006/main" xmlns:p="http://schemas.openxmlformats.org/presentationml/2006/main" xmlns:r="http://schemas.openxmlformats.org/officeDocument/2006/relationships">
   <p:cSld>
@@ -25059,7 +25811,7 @@
                 </a:solidFill>
                 <a:latin typeface="Arial"/>
               </a:rPr>
-              <a:t>22</a:t>
+              <a:t>23</a:t>
             </a:r>
           </a:p>
         </p:txBody>
@@ -26494,7 +27246,7 @@
                 </a:solidFill>
                 <a:latin typeface="Arial"/>
               </a:rPr>
-              <a:t>23</a:t>
+              <a:t>24</a:t>
             </a:r>
           </a:p>
         </p:txBody>

</xml_diff>